<commit_message>
- Andreea - 07.05.2026 - add curs 7 + restul de exercitii
</commit_message>
<xml_diff>
--- a/SUPORT-CURS/nbd-curs.pptx
+++ b/SUPORT-CURS/nbd-curs.pptx
@@ -168,7 +168,7 @@
           <p:cNvPr id="2" name="Title 1">
             <a:extLst>
               <a:ext uri="{FF2B5EF4-FFF2-40B4-BE49-F238E27FC236}">
-                <a16:creationId xmlns:a16="http://schemas.microsoft.com/office/drawing/2014/main" xmlns="" id="{D99A2FE3-1FDD-4E47-D310-FED3CDFAD312}"/>
+                <a16:creationId xmlns="" xmlns:a16="http://schemas.microsoft.com/office/drawing/2014/main" id="{D99A2FE3-1FDD-4E47-D310-FED3CDFAD312}"/>
               </a:ext>
             </a:extLst>
           </p:cNvPr>
@@ -206,7 +206,7 @@
           <p:cNvPr id="3" name="Subtitle 2">
             <a:extLst>
               <a:ext uri="{FF2B5EF4-FFF2-40B4-BE49-F238E27FC236}">
-                <a16:creationId xmlns:a16="http://schemas.microsoft.com/office/drawing/2014/main" xmlns="" id="{BF49F500-8777-04A1-18B9-558063541293}"/>
+                <a16:creationId xmlns="" xmlns:a16="http://schemas.microsoft.com/office/drawing/2014/main" id="{BF49F500-8777-04A1-18B9-558063541293}"/>
               </a:ext>
             </a:extLst>
           </p:cNvPr>
@@ -277,7 +277,7 @@
           <p:cNvPr id="4" name="Date Placeholder 3">
             <a:extLst>
               <a:ext uri="{FF2B5EF4-FFF2-40B4-BE49-F238E27FC236}">
-                <a16:creationId xmlns:a16="http://schemas.microsoft.com/office/drawing/2014/main" xmlns="" id="{EA677C15-7088-DBB0-E97A-8B51FCFAB1E8}"/>
+                <a16:creationId xmlns="" xmlns:a16="http://schemas.microsoft.com/office/drawing/2014/main" id="{EA677C15-7088-DBB0-E97A-8B51FCFAB1E8}"/>
               </a:ext>
             </a:extLst>
           </p:cNvPr>
@@ -306,7 +306,7 @@
           <p:cNvPr id="5" name="Footer Placeholder 4">
             <a:extLst>
               <a:ext uri="{FF2B5EF4-FFF2-40B4-BE49-F238E27FC236}">
-                <a16:creationId xmlns:a16="http://schemas.microsoft.com/office/drawing/2014/main" xmlns="" id="{B880F7A8-7F74-EC0A-A01F-718F8BD6793B}"/>
+                <a16:creationId xmlns="" xmlns:a16="http://schemas.microsoft.com/office/drawing/2014/main" id="{B880F7A8-7F74-EC0A-A01F-718F8BD6793B}"/>
               </a:ext>
             </a:extLst>
           </p:cNvPr>
@@ -331,7 +331,7 @@
           <p:cNvPr id="6" name="Slide Number Placeholder 5">
             <a:extLst>
               <a:ext uri="{FF2B5EF4-FFF2-40B4-BE49-F238E27FC236}">
-                <a16:creationId xmlns:a16="http://schemas.microsoft.com/office/drawing/2014/main" xmlns="" id="{2B532F58-BC68-9448-FDB9-22B258EAC06C}"/>
+                <a16:creationId xmlns="" xmlns:a16="http://schemas.microsoft.com/office/drawing/2014/main" id="{2B532F58-BC68-9448-FDB9-22B258EAC06C}"/>
               </a:ext>
             </a:extLst>
           </p:cNvPr>
@@ -390,7 +390,7 @@
           <p:cNvPr id="2" name="Title 1">
             <a:extLst>
               <a:ext uri="{FF2B5EF4-FFF2-40B4-BE49-F238E27FC236}">
-                <a16:creationId xmlns:a16="http://schemas.microsoft.com/office/drawing/2014/main" xmlns="" id="{309B1778-3C92-43C1-5547-440F4DC8D653}"/>
+                <a16:creationId xmlns="" xmlns:a16="http://schemas.microsoft.com/office/drawing/2014/main" id="{309B1778-3C92-43C1-5547-440F4DC8D653}"/>
               </a:ext>
             </a:extLst>
           </p:cNvPr>
@@ -419,7 +419,7 @@
           <p:cNvPr id="3" name="Vertical Text Placeholder 2">
             <a:extLst>
               <a:ext uri="{FF2B5EF4-FFF2-40B4-BE49-F238E27FC236}">
-                <a16:creationId xmlns:a16="http://schemas.microsoft.com/office/drawing/2014/main" xmlns="" id="{4CB6C1A5-2D8D-5F9B-EB5B-488BFFCFFDC6}"/>
+                <a16:creationId xmlns="" xmlns:a16="http://schemas.microsoft.com/office/drawing/2014/main" id="{4CB6C1A5-2D8D-5F9B-EB5B-488BFFCFFDC6}"/>
               </a:ext>
             </a:extLst>
           </p:cNvPr>
@@ -477,7 +477,7 @@
           <p:cNvPr id="4" name="Date Placeholder 3">
             <a:extLst>
               <a:ext uri="{FF2B5EF4-FFF2-40B4-BE49-F238E27FC236}">
-                <a16:creationId xmlns:a16="http://schemas.microsoft.com/office/drawing/2014/main" xmlns="" id="{66202BC7-99BA-C3A8-80E8-7E8F52A7F85B}"/>
+                <a16:creationId xmlns="" xmlns:a16="http://schemas.microsoft.com/office/drawing/2014/main" id="{66202BC7-99BA-C3A8-80E8-7E8F52A7F85B}"/>
               </a:ext>
             </a:extLst>
           </p:cNvPr>
@@ -506,7 +506,7 @@
           <p:cNvPr id="5" name="Footer Placeholder 4">
             <a:extLst>
               <a:ext uri="{FF2B5EF4-FFF2-40B4-BE49-F238E27FC236}">
-                <a16:creationId xmlns:a16="http://schemas.microsoft.com/office/drawing/2014/main" xmlns="" id="{DAD0D734-FC85-1725-6B5D-EC662DE7B92F}"/>
+                <a16:creationId xmlns="" xmlns:a16="http://schemas.microsoft.com/office/drawing/2014/main" id="{DAD0D734-FC85-1725-6B5D-EC662DE7B92F}"/>
               </a:ext>
             </a:extLst>
           </p:cNvPr>
@@ -531,7 +531,7 @@
           <p:cNvPr id="6" name="Slide Number Placeholder 5">
             <a:extLst>
               <a:ext uri="{FF2B5EF4-FFF2-40B4-BE49-F238E27FC236}">
-                <a16:creationId xmlns:a16="http://schemas.microsoft.com/office/drawing/2014/main" xmlns="" id="{9501279C-782A-82D9-2A31-65F7F9610EFD}"/>
+                <a16:creationId xmlns="" xmlns:a16="http://schemas.microsoft.com/office/drawing/2014/main" id="{9501279C-782A-82D9-2A31-65F7F9610EFD}"/>
               </a:ext>
             </a:extLst>
           </p:cNvPr>
@@ -590,7 +590,7 @@
           <p:cNvPr id="2" name="Vertical Title 1">
             <a:extLst>
               <a:ext uri="{FF2B5EF4-FFF2-40B4-BE49-F238E27FC236}">
-                <a16:creationId xmlns:a16="http://schemas.microsoft.com/office/drawing/2014/main" xmlns="" id="{733AE944-0BBE-6B89-8F04-BB8726BFE0EE}"/>
+                <a16:creationId xmlns="" xmlns:a16="http://schemas.microsoft.com/office/drawing/2014/main" id="{733AE944-0BBE-6B89-8F04-BB8726BFE0EE}"/>
               </a:ext>
             </a:extLst>
           </p:cNvPr>
@@ -624,7 +624,7 @@
           <p:cNvPr id="3" name="Vertical Text Placeholder 2">
             <a:extLst>
               <a:ext uri="{FF2B5EF4-FFF2-40B4-BE49-F238E27FC236}">
-                <a16:creationId xmlns:a16="http://schemas.microsoft.com/office/drawing/2014/main" xmlns="" id="{FD318C0C-573B-1418-A398-B0E6B5AD08D1}"/>
+                <a16:creationId xmlns="" xmlns:a16="http://schemas.microsoft.com/office/drawing/2014/main" id="{FD318C0C-573B-1418-A398-B0E6B5AD08D1}"/>
               </a:ext>
             </a:extLst>
           </p:cNvPr>
@@ -687,7 +687,7 @@
           <p:cNvPr id="4" name="Date Placeholder 3">
             <a:extLst>
               <a:ext uri="{FF2B5EF4-FFF2-40B4-BE49-F238E27FC236}">
-                <a16:creationId xmlns:a16="http://schemas.microsoft.com/office/drawing/2014/main" xmlns="" id="{9552A9CA-D234-0F1C-EDD8-CD420174BEBE}"/>
+                <a16:creationId xmlns="" xmlns:a16="http://schemas.microsoft.com/office/drawing/2014/main" id="{9552A9CA-D234-0F1C-EDD8-CD420174BEBE}"/>
               </a:ext>
             </a:extLst>
           </p:cNvPr>
@@ -716,7 +716,7 @@
           <p:cNvPr id="5" name="Footer Placeholder 4">
             <a:extLst>
               <a:ext uri="{FF2B5EF4-FFF2-40B4-BE49-F238E27FC236}">
-                <a16:creationId xmlns:a16="http://schemas.microsoft.com/office/drawing/2014/main" xmlns="" id="{8317C57F-6B27-5B9C-13C6-1572C75DC624}"/>
+                <a16:creationId xmlns="" xmlns:a16="http://schemas.microsoft.com/office/drawing/2014/main" id="{8317C57F-6B27-5B9C-13C6-1572C75DC624}"/>
               </a:ext>
             </a:extLst>
           </p:cNvPr>
@@ -741,7 +741,7 @@
           <p:cNvPr id="6" name="Slide Number Placeholder 5">
             <a:extLst>
               <a:ext uri="{FF2B5EF4-FFF2-40B4-BE49-F238E27FC236}">
-                <a16:creationId xmlns:a16="http://schemas.microsoft.com/office/drawing/2014/main" xmlns="" id="{6C93990D-6AF8-BD56-B689-727FF03A3ECB}"/>
+                <a16:creationId xmlns="" xmlns:a16="http://schemas.microsoft.com/office/drawing/2014/main" id="{6C93990D-6AF8-BD56-B689-727FF03A3ECB}"/>
               </a:ext>
             </a:extLst>
           </p:cNvPr>
@@ -800,7 +800,7 @@
           <p:cNvPr id="2" name="Title 1">
             <a:extLst>
               <a:ext uri="{FF2B5EF4-FFF2-40B4-BE49-F238E27FC236}">
-                <a16:creationId xmlns:a16="http://schemas.microsoft.com/office/drawing/2014/main" xmlns="" id="{1B763131-AF4E-34E4-9E4C-A89A2C0A0CC3}"/>
+                <a16:creationId xmlns="" xmlns:a16="http://schemas.microsoft.com/office/drawing/2014/main" id="{1B763131-AF4E-34E4-9E4C-A89A2C0A0CC3}"/>
               </a:ext>
             </a:extLst>
           </p:cNvPr>
@@ -829,7 +829,7 @@
           <p:cNvPr id="3" name="Content Placeholder 2">
             <a:extLst>
               <a:ext uri="{FF2B5EF4-FFF2-40B4-BE49-F238E27FC236}">
-                <a16:creationId xmlns:a16="http://schemas.microsoft.com/office/drawing/2014/main" xmlns="" id="{E4C8CEFC-B865-15BD-B7E7-C1E77C141E5E}"/>
+                <a16:creationId xmlns="" xmlns:a16="http://schemas.microsoft.com/office/drawing/2014/main" id="{E4C8CEFC-B865-15BD-B7E7-C1E77C141E5E}"/>
               </a:ext>
             </a:extLst>
           </p:cNvPr>
@@ -887,7 +887,7 @@
           <p:cNvPr id="4" name="Date Placeholder 3">
             <a:extLst>
               <a:ext uri="{FF2B5EF4-FFF2-40B4-BE49-F238E27FC236}">
-                <a16:creationId xmlns:a16="http://schemas.microsoft.com/office/drawing/2014/main" xmlns="" id="{DAE7399E-E373-4485-7404-40B6AF3772FB}"/>
+                <a16:creationId xmlns="" xmlns:a16="http://schemas.microsoft.com/office/drawing/2014/main" id="{DAE7399E-E373-4485-7404-40B6AF3772FB}"/>
               </a:ext>
             </a:extLst>
           </p:cNvPr>
@@ -916,7 +916,7 @@
           <p:cNvPr id="5" name="Footer Placeholder 4">
             <a:extLst>
               <a:ext uri="{FF2B5EF4-FFF2-40B4-BE49-F238E27FC236}">
-                <a16:creationId xmlns:a16="http://schemas.microsoft.com/office/drawing/2014/main" xmlns="" id="{963650D2-2175-FA41-0336-C6D4BA1C4456}"/>
+                <a16:creationId xmlns="" xmlns:a16="http://schemas.microsoft.com/office/drawing/2014/main" id="{963650D2-2175-FA41-0336-C6D4BA1C4456}"/>
               </a:ext>
             </a:extLst>
           </p:cNvPr>
@@ -941,7 +941,7 @@
           <p:cNvPr id="6" name="Slide Number Placeholder 5">
             <a:extLst>
               <a:ext uri="{FF2B5EF4-FFF2-40B4-BE49-F238E27FC236}">
-                <a16:creationId xmlns:a16="http://schemas.microsoft.com/office/drawing/2014/main" xmlns="" id="{A68CB38E-5CF0-1DDF-857F-F91A2CDEF7BD}"/>
+                <a16:creationId xmlns="" xmlns:a16="http://schemas.microsoft.com/office/drawing/2014/main" id="{A68CB38E-5CF0-1DDF-857F-F91A2CDEF7BD}"/>
               </a:ext>
             </a:extLst>
           </p:cNvPr>
@@ -1000,7 +1000,7 @@
           <p:cNvPr id="2" name="Title 1">
             <a:extLst>
               <a:ext uri="{FF2B5EF4-FFF2-40B4-BE49-F238E27FC236}">
-                <a16:creationId xmlns:a16="http://schemas.microsoft.com/office/drawing/2014/main" xmlns="" id="{7D3F70A3-1FA3-7BD4-1EC4-5089762A0B15}"/>
+                <a16:creationId xmlns="" xmlns:a16="http://schemas.microsoft.com/office/drawing/2014/main" id="{7D3F70A3-1FA3-7BD4-1EC4-5089762A0B15}"/>
               </a:ext>
             </a:extLst>
           </p:cNvPr>
@@ -1038,7 +1038,7 @@
           <p:cNvPr id="3" name="Text Placeholder 2">
             <a:extLst>
               <a:ext uri="{FF2B5EF4-FFF2-40B4-BE49-F238E27FC236}">
-                <a16:creationId xmlns:a16="http://schemas.microsoft.com/office/drawing/2014/main" xmlns="" id="{B0E7B0A6-900F-34EC-3F8E-5C23A0BB2B4B}"/>
+                <a16:creationId xmlns="" xmlns:a16="http://schemas.microsoft.com/office/drawing/2014/main" id="{B0E7B0A6-900F-34EC-3F8E-5C23A0BB2B4B}"/>
               </a:ext>
             </a:extLst>
           </p:cNvPr>
@@ -1163,7 +1163,7 @@
           <p:cNvPr id="4" name="Date Placeholder 3">
             <a:extLst>
               <a:ext uri="{FF2B5EF4-FFF2-40B4-BE49-F238E27FC236}">
-                <a16:creationId xmlns:a16="http://schemas.microsoft.com/office/drawing/2014/main" xmlns="" id="{B2D1F427-24CB-DE7E-8911-5FFFEE1F34D3}"/>
+                <a16:creationId xmlns="" xmlns:a16="http://schemas.microsoft.com/office/drawing/2014/main" id="{B2D1F427-24CB-DE7E-8911-5FFFEE1F34D3}"/>
               </a:ext>
             </a:extLst>
           </p:cNvPr>
@@ -1192,7 +1192,7 @@
           <p:cNvPr id="5" name="Footer Placeholder 4">
             <a:extLst>
               <a:ext uri="{FF2B5EF4-FFF2-40B4-BE49-F238E27FC236}">
-                <a16:creationId xmlns:a16="http://schemas.microsoft.com/office/drawing/2014/main" xmlns="" id="{11C18909-3F10-0A72-839B-1097E8A04370}"/>
+                <a16:creationId xmlns="" xmlns:a16="http://schemas.microsoft.com/office/drawing/2014/main" id="{11C18909-3F10-0A72-839B-1097E8A04370}"/>
               </a:ext>
             </a:extLst>
           </p:cNvPr>
@@ -1217,7 +1217,7 @@
           <p:cNvPr id="6" name="Slide Number Placeholder 5">
             <a:extLst>
               <a:ext uri="{FF2B5EF4-FFF2-40B4-BE49-F238E27FC236}">
-                <a16:creationId xmlns:a16="http://schemas.microsoft.com/office/drawing/2014/main" xmlns="" id="{3145F1A3-C3E5-80DE-2559-DAD5D4EA8302}"/>
+                <a16:creationId xmlns="" xmlns:a16="http://schemas.microsoft.com/office/drawing/2014/main" id="{3145F1A3-C3E5-80DE-2559-DAD5D4EA8302}"/>
               </a:ext>
             </a:extLst>
           </p:cNvPr>
@@ -1276,7 +1276,7 @@
           <p:cNvPr id="2" name="Title 1">
             <a:extLst>
               <a:ext uri="{FF2B5EF4-FFF2-40B4-BE49-F238E27FC236}">
-                <a16:creationId xmlns:a16="http://schemas.microsoft.com/office/drawing/2014/main" xmlns="" id="{704BCEC0-8B46-E6F7-AEFA-F6C04C4F0AD8}"/>
+                <a16:creationId xmlns="" xmlns:a16="http://schemas.microsoft.com/office/drawing/2014/main" id="{704BCEC0-8B46-E6F7-AEFA-F6C04C4F0AD8}"/>
               </a:ext>
             </a:extLst>
           </p:cNvPr>
@@ -1305,7 +1305,7 @@
           <p:cNvPr id="3" name="Content Placeholder 2">
             <a:extLst>
               <a:ext uri="{FF2B5EF4-FFF2-40B4-BE49-F238E27FC236}">
-                <a16:creationId xmlns:a16="http://schemas.microsoft.com/office/drawing/2014/main" xmlns="" id="{82B3D759-ACBE-FDC3-F75E-730B386B1C9D}"/>
+                <a16:creationId xmlns="" xmlns:a16="http://schemas.microsoft.com/office/drawing/2014/main" id="{82B3D759-ACBE-FDC3-F75E-730B386B1C9D}"/>
               </a:ext>
             </a:extLst>
           </p:cNvPr>
@@ -1368,7 +1368,7 @@
           <p:cNvPr id="4" name="Content Placeholder 3">
             <a:extLst>
               <a:ext uri="{FF2B5EF4-FFF2-40B4-BE49-F238E27FC236}">
-                <a16:creationId xmlns:a16="http://schemas.microsoft.com/office/drawing/2014/main" xmlns="" id="{CC609083-786C-5F71-B471-F05238F130DC}"/>
+                <a16:creationId xmlns="" xmlns:a16="http://schemas.microsoft.com/office/drawing/2014/main" id="{CC609083-786C-5F71-B471-F05238F130DC}"/>
               </a:ext>
             </a:extLst>
           </p:cNvPr>
@@ -1431,7 +1431,7 @@
           <p:cNvPr id="5" name="Date Placeholder 4">
             <a:extLst>
               <a:ext uri="{FF2B5EF4-FFF2-40B4-BE49-F238E27FC236}">
-                <a16:creationId xmlns:a16="http://schemas.microsoft.com/office/drawing/2014/main" xmlns="" id="{B9A6E949-D725-4EE4-3757-DC2108CA3C80}"/>
+                <a16:creationId xmlns="" xmlns:a16="http://schemas.microsoft.com/office/drawing/2014/main" id="{B9A6E949-D725-4EE4-3757-DC2108CA3C80}"/>
               </a:ext>
             </a:extLst>
           </p:cNvPr>
@@ -1460,7 +1460,7 @@
           <p:cNvPr id="6" name="Footer Placeholder 5">
             <a:extLst>
               <a:ext uri="{FF2B5EF4-FFF2-40B4-BE49-F238E27FC236}">
-                <a16:creationId xmlns:a16="http://schemas.microsoft.com/office/drawing/2014/main" xmlns="" id="{471607B6-8496-805D-B3A0-2CB687BADDDE}"/>
+                <a16:creationId xmlns="" xmlns:a16="http://schemas.microsoft.com/office/drawing/2014/main" id="{471607B6-8496-805D-B3A0-2CB687BADDDE}"/>
               </a:ext>
             </a:extLst>
           </p:cNvPr>
@@ -1485,7 +1485,7 @@
           <p:cNvPr id="7" name="Slide Number Placeholder 6">
             <a:extLst>
               <a:ext uri="{FF2B5EF4-FFF2-40B4-BE49-F238E27FC236}">
-                <a16:creationId xmlns:a16="http://schemas.microsoft.com/office/drawing/2014/main" xmlns="" id="{A44EDEB4-A3CF-888B-580F-4ADC2732FCA9}"/>
+                <a16:creationId xmlns="" xmlns:a16="http://schemas.microsoft.com/office/drawing/2014/main" id="{A44EDEB4-A3CF-888B-580F-4ADC2732FCA9}"/>
               </a:ext>
             </a:extLst>
           </p:cNvPr>
@@ -1544,7 +1544,7 @@
           <p:cNvPr id="2" name="Title 1">
             <a:extLst>
               <a:ext uri="{FF2B5EF4-FFF2-40B4-BE49-F238E27FC236}">
-                <a16:creationId xmlns:a16="http://schemas.microsoft.com/office/drawing/2014/main" xmlns="" id="{33CE5381-CB67-9F5D-8102-7252816ABDD6}"/>
+                <a16:creationId xmlns="" xmlns:a16="http://schemas.microsoft.com/office/drawing/2014/main" id="{33CE5381-CB67-9F5D-8102-7252816ABDD6}"/>
               </a:ext>
             </a:extLst>
           </p:cNvPr>
@@ -1578,7 +1578,7 @@
           <p:cNvPr id="3" name="Text Placeholder 2">
             <a:extLst>
               <a:ext uri="{FF2B5EF4-FFF2-40B4-BE49-F238E27FC236}">
-                <a16:creationId xmlns:a16="http://schemas.microsoft.com/office/drawing/2014/main" xmlns="" id="{7500C4AA-EB8A-EA2F-CF82-3FB62FB289BE}"/>
+                <a16:creationId xmlns="" xmlns:a16="http://schemas.microsoft.com/office/drawing/2014/main" id="{7500C4AA-EB8A-EA2F-CF82-3FB62FB289BE}"/>
               </a:ext>
             </a:extLst>
           </p:cNvPr>
@@ -1649,7 +1649,7 @@
           <p:cNvPr id="4" name="Content Placeholder 3">
             <a:extLst>
               <a:ext uri="{FF2B5EF4-FFF2-40B4-BE49-F238E27FC236}">
-                <a16:creationId xmlns:a16="http://schemas.microsoft.com/office/drawing/2014/main" xmlns="" id="{F3813281-18B3-69C9-767E-56F3DC54DF08}"/>
+                <a16:creationId xmlns="" xmlns:a16="http://schemas.microsoft.com/office/drawing/2014/main" id="{F3813281-18B3-69C9-767E-56F3DC54DF08}"/>
               </a:ext>
             </a:extLst>
           </p:cNvPr>
@@ -1712,7 +1712,7 @@
           <p:cNvPr id="5" name="Text Placeholder 4">
             <a:extLst>
               <a:ext uri="{FF2B5EF4-FFF2-40B4-BE49-F238E27FC236}">
-                <a16:creationId xmlns:a16="http://schemas.microsoft.com/office/drawing/2014/main" xmlns="" id="{1EF7B2A9-AC47-FFFE-55D9-BB23CD9B79A5}"/>
+                <a16:creationId xmlns="" xmlns:a16="http://schemas.microsoft.com/office/drawing/2014/main" id="{1EF7B2A9-AC47-FFFE-55D9-BB23CD9B79A5}"/>
               </a:ext>
             </a:extLst>
           </p:cNvPr>
@@ -1783,7 +1783,7 @@
           <p:cNvPr id="6" name="Content Placeholder 5">
             <a:extLst>
               <a:ext uri="{FF2B5EF4-FFF2-40B4-BE49-F238E27FC236}">
-                <a16:creationId xmlns:a16="http://schemas.microsoft.com/office/drawing/2014/main" xmlns="" id="{C7C3A63E-5050-4839-0A35-8DCF91942520}"/>
+                <a16:creationId xmlns="" xmlns:a16="http://schemas.microsoft.com/office/drawing/2014/main" id="{C7C3A63E-5050-4839-0A35-8DCF91942520}"/>
               </a:ext>
             </a:extLst>
           </p:cNvPr>
@@ -1846,7 +1846,7 @@
           <p:cNvPr id="7" name="Date Placeholder 6">
             <a:extLst>
               <a:ext uri="{FF2B5EF4-FFF2-40B4-BE49-F238E27FC236}">
-                <a16:creationId xmlns:a16="http://schemas.microsoft.com/office/drawing/2014/main" xmlns="" id="{F6C56185-1BE8-53B5-BB88-80FFF6C46833}"/>
+                <a16:creationId xmlns="" xmlns:a16="http://schemas.microsoft.com/office/drawing/2014/main" id="{F6C56185-1BE8-53B5-BB88-80FFF6C46833}"/>
               </a:ext>
             </a:extLst>
           </p:cNvPr>
@@ -1875,7 +1875,7 @@
           <p:cNvPr id="8" name="Footer Placeholder 7">
             <a:extLst>
               <a:ext uri="{FF2B5EF4-FFF2-40B4-BE49-F238E27FC236}">
-                <a16:creationId xmlns:a16="http://schemas.microsoft.com/office/drawing/2014/main" xmlns="" id="{D03F5919-C836-5537-2AAA-3E6D71B07A6C}"/>
+                <a16:creationId xmlns="" xmlns:a16="http://schemas.microsoft.com/office/drawing/2014/main" id="{D03F5919-C836-5537-2AAA-3E6D71B07A6C}"/>
               </a:ext>
             </a:extLst>
           </p:cNvPr>
@@ -1900,7 +1900,7 @@
           <p:cNvPr id="9" name="Slide Number Placeholder 8">
             <a:extLst>
               <a:ext uri="{FF2B5EF4-FFF2-40B4-BE49-F238E27FC236}">
-                <a16:creationId xmlns:a16="http://schemas.microsoft.com/office/drawing/2014/main" xmlns="" id="{A8E0AAC0-6820-49D5-A93C-89996DD7CD82}"/>
+                <a16:creationId xmlns="" xmlns:a16="http://schemas.microsoft.com/office/drawing/2014/main" id="{A8E0AAC0-6820-49D5-A93C-89996DD7CD82}"/>
               </a:ext>
             </a:extLst>
           </p:cNvPr>
@@ -1959,7 +1959,7 @@
           <p:cNvPr id="2" name="Title 1">
             <a:extLst>
               <a:ext uri="{FF2B5EF4-FFF2-40B4-BE49-F238E27FC236}">
-                <a16:creationId xmlns:a16="http://schemas.microsoft.com/office/drawing/2014/main" xmlns="" id="{7D2537F6-6F11-0A43-A1B8-EFFF5C2C7819}"/>
+                <a16:creationId xmlns="" xmlns:a16="http://schemas.microsoft.com/office/drawing/2014/main" id="{7D2537F6-6F11-0A43-A1B8-EFFF5C2C7819}"/>
               </a:ext>
             </a:extLst>
           </p:cNvPr>
@@ -1988,7 +1988,7 @@
           <p:cNvPr id="3" name="Date Placeholder 2">
             <a:extLst>
               <a:ext uri="{FF2B5EF4-FFF2-40B4-BE49-F238E27FC236}">
-                <a16:creationId xmlns:a16="http://schemas.microsoft.com/office/drawing/2014/main" xmlns="" id="{B9220719-6AEB-AD77-B129-D9866E1A0DBA}"/>
+                <a16:creationId xmlns="" xmlns:a16="http://schemas.microsoft.com/office/drawing/2014/main" id="{B9220719-6AEB-AD77-B129-D9866E1A0DBA}"/>
               </a:ext>
             </a:extLst>
           </p:cNvPr>
@@ -2017,7 +2017,7 @@
           <p:cNvPr id="4" name="Footer Placeholder 3">
             <a:extLst>
               <a:ext uri="{FF2B5EF4-FFF2-40B4-BE49-F238E27FC236}">
-                <a16:creationId xmlns:a16="http://schemas.microsoft.com/office/drawing/2014/main" xmlns="" id="{5628E2D9-AC94-BF6D-F4B8-D9EF0DEFD309}"/>
+                <a16:creationId xmlns="" xmlns:a16="http://schemas.microsoft.com/office/drawing/2014/main" id="{5628E2D9-AC94-BF6D-F4B8-D9EF0DEFD309}"/>
               </a:ext>
             </a:extLst>
           </p:cNvPr>
@@ -2042,7 +2042,7 @@
           <p:cNvPr id="5" name="Slide Number Placeholder 4">
             <a:extLst>
               <a:ext uri="{FF2B5EF4-FFF2-40B4-BE49-F238E27FC236}">
-                <a16:creationId xmlns:a16="http://schemas.microsoft.com/office/drawing/2014/main" xmlns="" id="{6C09F835-180E-08B8-8B9F-B3DB7569C80F}"/>
+                <a16:creationId xmlns="" xmlns:a16="http://schemas.microsoft.com/office/drawing/2014/main" id="{6C09F835-180E-08B8-8B9F-B3DB7569C80F}"/>
               </a:ext>
             </a:extLst>
           </p:cNvPr>
@@ -2101,7 +2101,7 @@
           <p:cNvPr id="2" name="Date Placeholder 1">
             <a:extLst>
               <a:ext uri="{FF2B5EF4-FFF2-40B4-BE49-F238E27FC236}">
-                <a16:creationId xmlns:a16="http://schemas.microsoft.com/office/drawing/2014/main" xmlns="" id="{0D1488D8-6EE3-88DF-B88E-7334AC270C72}"/>
+                <a16:creationId xmlns="" xmlns:a16="http://schemas.microsoft.com/office/drawing/2014/main" id="{0D1488D8-6EE3-88DF-B88E-7334AC270C72}"/>
               </a:ext>
             </a:extLst>
           </p:cNvPr>
@@ -2130,7 +2130,7 @@
           <p:cNvPr id="3" name="Footer Placeholder 2">
             <a:extLst>
               <a:ext uri="{FF2B5EF4-FFF2-40B4-BE49-F238E27FC236}">
-                <a16:creationId xmlns:a16="http://schemas.microsoft.com/office/drawing/2014/main" xmlns="" id="{6DC85F7C-1847-8942-888D-E6DE66A39C28}"/>
+                <a16:creationId xmlns="" xmlns:a16="http://schemas.microsoft.com/office/drawing/2014/main" id="{6DC85F7C-1847-8942-888D-E6DE66A39C28}"/>
               </a:ext>
             </a:extLst>
           </p:cNvPr>
@@ -2155,7 +2155,7 @@
           <p:cNvPr id="4" name="Slide Number Placeholder 3">
             <a:extLst>
               <a:ext uri="{FF2B5EF4-FFF2-40B4-BE49-F238E27FC236}">
-                <a16:creationId xmlns:a16="http://schemas.microsoft.com/office/drawing/2014/main" xmlns="" id="{A661BABF-0257-80B3-78A3-9969B1F337EB}"/>
+                <a16:creationId xmlns="" xmlns:a16="http://schemas.microsoft.com/office/drawing/2014/main" id="{A661BABF-0257-80B3-78A3-9969B1F337EB}"/>
               </a:ext>
             </a:extLst>
           </p:cNvPr>
@@ -2214,7 +2214,7 @@
           <p:cNvPr id="2" name="Title 1">
             <a:extLst>
               <a:ext uri="{FF2B5EF4-FFF2-40B4-BE49-F238E27FC236}">
-                <a16:creationId xmlns:a16="http://schemas.microsoft.com/office/drawing/2014/main" xmlns="" id="{5209AC72-4582-2509-CFCF-F4DEB4D722E1}"/>
+                <a16:creationId xmlns="" xmlns:a16="http://schemas.microsoft.com/office/drawing/2014/main" id="{5209AC72-4582-2509-CFCF-F4DEB4D722E1}"/>
               </a:ext>
             </a:extLst>
           </p:cNvPr>
@@ -2252,7 +2252,7 @@
           <p:cNvPr id="3" name="Content Placeholder 2">
             <a:extLst>
               <a:ext uri="{FF2B5EF4-FFF2-40B4-BE49-F238E27FC236}">
-                <a16:creationId xmlns:a16="http://schemas.microsoft.com/office/drawing/2014/main" xmlns="" id="{B2A1436E-6FCA-74E8-FC1D-3F41B1B27951}"/>
+                <a16:creationId xmlns="" xmlns:a16="http://schemas.microsoft.com/office/drawing/2014/main" id="{B2A1436E-6FCA-74E8-FC1D-3F41B1B27951}"/>
               </a:ext>
             </a:extLst>
           </p:cNvPr>
@@ -2343,7 +2343,7 @@
           <p:cNvPr id="4" name="Text Placeholder 3">
             <a:extLst>
               <a:ext uri="{FF2B5EF4-FFF2-40B4-BE49-F238E27FC236}">
-                <a16:creationId xmlns:a16="http://schemas.microsoft.com/office/drawing/2014/main" xmlns="" id="{004F8832-5BC2-85BE-C163-F831A154D800}"/>
+                <a16:creationId xmlns="" xmlns:a16="http://schemas.microsoft.com/office/drawing/2014/main" id="{004F8832-5BC2-85BE-C163-F831A154D800}"/>
               </a:ext>
             </a:extLst>
           </p:cNvPr>
@@ -2414,7 +2414,7 @@
           <p:cNvPr id="5" name="Date Placeholder 4">
             <a:extLst>
               <a:ext uri="{FF2B5EF4-FFF2-40B4-BE49-F238E27FC236}">
-                <a16:creationId xmlns:a16="http://schemas.microsoft.com/office/drawing/2014/main" xmlns="" id="{30F3BA15-7C9E-FE56-A33D-15B3C82FD09A}"/>
+                <a16:creationId xmlns="" xmlns:a16="http://schemas.microsoft.com/office/drawing/2014/main" id="{30F3BA15-7C9E-FE56-A33D-15B3C82FD09A}"/>
               </a:ext>
             </a:extLst>
           </p:cNvPr>
@@ -2443,7 +2443,7 @@
           <p:cNvPr id="6" name="Footer Placeholder 5">
             <a:extLst>
               <a:ext uri="{FF2B5EF4-FFF2-40B4-BE49-F238E27FC236}">
-                <a16:creationId xmlns:a16="http://schemas.microsoft.com/office/drawing/2014/main" xmlns="" id="{EEB92FA7-DAB2-1E0C-4263-BECED5D1FAEF}"/>
+                <a16:creationId xmlns="" xmlns:a16="http://schemas.microsoft.com/office/drawing/2014/main" id="{EEB92FA7-DAB2-1E0C-4263-BECED5D1FAEF}"/>
               </a:ext>
             </a:extLst>
           </p:cNvPr>
@@ -2468,7 +2468,7 @@
           <p:cNvPr id="7" name="Slide Number Placeholder 6">
             <a:extLst>
               <a:ext uri="{FF2B5EF4-FFF2-40B4-BE49-F238E27FC236}">
-                <a16:creationId xmlns:a16="http://schemas.microsoft.com/office/drawing/2014/main" xmlns="" id="{5DB49C63-18AE-91CA-D5B9-689C4B1C20B0}"/>
+                <a16:creationId xmlns="" xmlns:a16="http://schemas.microsoft.com/office/drawing/2014/main" id="{5DB49C63-18AE-91CA-D5B9-689C4B1C20B0}"/>
               </a:ext>
             </a:extLst>
           </p:cNvPr>
@@ -2527,7 +2527,7 @@
           <p:cNvPr id="2" name="Title 1">
             <a:extLst>
               <a:ext uri="{FF2B5EF4-FFF2-40B4-BE49-F238E27FC236}">
-                <a16:creationId xmlns:a16="http://schemas.microsoft.com/office/drawing/2014/main" xmlns="" id="{28A5563E-E196-7227-1846-15751DEF66B4}"/>
+                <a16:creationId xmlns="" xmlns:a16="http://schemas.microsoft.com/office/drawing/2014/main" id="{28A5563E-E196-7227-1846-15751DEF66B4}"/>
               </a:ext>
             </a:extLst>
           </p:cNvPr>
@@ -2565,7 +2565,7 @@
           <p:cNvPr id="3" name="Picture Placeholder 2">
             <a:extLst>
               <a:ext uri="{FF2B5EF4-FFF2-40B4-BE49-F238E27FC236}">
-                <a16:creationId xmlns:a16="http://schemas.microsoft.com/office/drawing/2014/main" xmlns="" id="{DBB59F14-D985-43D2-5A22-87FAAF11376B}"/>
+                <a16:creationId xmlns="" xmlns:a16="http://schemas.microsoft.com/office/drawing/2014/main" id="{DBB59F14-D985-43D2-5A22-87FAAF11376B}"/>
               </a:ext>
             </a:extLst>
           </p:cNvPr>
@@ -2632,7 +2632,7 @@
           <p:cNvPr id="4" name="Text Placeholder 3">
             <a:extLst>
               <a:ext uri="{FF2B5EF4-FFF2-40B4-BE49-F238E27FC236}">
-                <a16:creationId xmlns:a16="http://schemas.microsoft.com/office/drawing/2014/main" xmlns="" id="{7A68A2F6-4593-FAD2-C828-1E7534AB2E72}"/>
+                <a16:creationId xmlns="" xmlns:a16="http://schemas.microsoft.com/office/drawing/2014/main" id="{7A68A2F6-4593-FAD2-C828-1E7534AB2E72}"/>
               </a:ext>
             </a:extLst>
           </p:cNvPr>
@@ -2703,7 +2703,7 @@
           <p:cNvPr id="5" name="Date Placeholder 4">
             <a:extLst>
               <a:ext uri="{FF2B5EF4-FFF2-40B4-BE49-F238E27FC236}">
-                <a16:creationId xmlns:a16="http://schemas.microsoft.com/office/drawing/2014/main" xmlns="" id="{8D38ECD8-9DE5-01D9-4D1D-4F4EC3B2AB03}"/>
+                <a16:creationId xmlns="" xmlns:a16="http://schemas.microsoft.com/office/drawing/2014/main" id="{8D38ECD8-9DE5-01D9-4D1D-4F4EC3B2AB03}"/>
               </a:ext>
             </a:extLst>
           </p:cNvPr>
@@ -2732,7 +2732,7 @@
           <p:cNvPr id="6" name="Footer Placeholder 5">
             <a:extLst>
               <a:ext uri="{FF2B5EF4-FFF2-40B4-BE49-F238E27FC236}">
-                <a16:creationId xmlns:a16="http://schemas.microsoft.com/office/drawing/2014/main" xmlns="" id="{FCA3DAED-C6EF-2C87-1C27-EECD414C3563}"/>
+                <a16:creationId xmlns="" xmlns:a16="http://schemas.microsoft.com/office/drawing/2014/main" id="{FCA3DAED-C6EF-2C87-1C27-EECD414C3563}"/>
               </a:ext>
             </a:extLst>
           </p:cNvPr>
@@ -2757,7 +2757,7 @@
           <p:cNvPr id="7" name="Slide Number Placeholder 6">
             <a:extLst>
               <a:ext uri="{FF2B5EF4-FFF2-40B4-BE49-F238E27FC236}">
-                <a16:creationId xmlns:a16="http://schemas.microsoft.com/office/drawing/2014/main" xmlns="" id="{2D396A6D-736E-97B3-A15C-88FDD3AA0787}"/>
+                <a16:creationId xmlns="" xmlns:a16="http://schemas.microsoft.com/office/drawing/2014/main" id="{2D396A6D-736E-97B3-A15C-88FDD3AA0787}"/>
               </a:ext>
             </a:extLst>
           </p:cNvPr>
@@ -2821,7 +2821,7 @@
           <p:cNvPr id="2" name="Title Placeholder 1">
             <a:extLst>
               <a:ext uri="{FF2B5EF4-FFF2-40B4-BE49-F238E27FC236}">
-                <a16:creationId xmlns:a16="http://schemas.microsoft.com/office/drawing/2014/main" xmlns="" id="{C35EA045-E0CC-D6E2-2A1E-3498424037DC}"/>
+                <a16:creationId xmlns="" xmlns:a16="http://schemas.microsoft.com/office/drawing/2014/main" id="{C35EA045-E0CC-D6E2-2A1E-3498424037DC}"/>
               </a:ext>
             </a:extLst>
           </p:cNvPr>
@@ -2860,7 +2860,7 @@
           <p:cNvPr id="3" name="Text Placeholder 2">
             <a:extLst>
               <a:ext uri="{FF2B5EF4-FFF2-40B4-BE49-F238E27FC236}">
-                <a16:creationId xmlns:a16="http://schemas.microsoft.com/office/drawing/2014/main" xmlns="" id="{AB83CC0A-0A76-2243-FEDD-FE742A0159E8}"/>
+                <a16:creationId xmlns="" xmlns:a16="http://schemas.microsoft.com/office/drawing/2014/main" id="{AB83CC0A-0A76-2243-FEDD-FE742A0159E8}"/>
               </a:ext>
             </a:extLst>
           </p:cNvPr>
@@ -2928,7 +2928,7 @@
           <p:cNvPr id="4" name="Date Placeholder 3">
             <a:extLst>
               <a:ext uri="{FF2B5EF4-FFF2-40B4-BE49-F238E27FC236}">
-                <a16:creationId xmlns:a16="http://schemas.microsoft.com/office/drawing/2014/main" xmlns="" id="{93895A17-C54F-5BC8-65D6-489DDCDF1197}"/>
+                <a16:creationId xmlns="" xmlns:a16="http://schemas.microsoft.com/office/drawing/2014/main" id="{93895A17-C54F-5BC8-65D6-489DDCDF1197}"/>
               </a:ext>
             </a:extLst>
           </p:cNvPr>
@@ -2975,7 +2975,7 @@
           <p:cNvPr id="5" name="Footer Placeholder 4">
             <a:extLst>
               <a:ext uri="{FF2B5EF4-FFF2-40B4-BE49-F238E27FC236}">
-                <a16:creationId xmlns:a16="http://schemas.microsoft.com/office/drawing/2014/main" xmlns="" id="{41A511B0-BA90-A165-AE00-CBE74FF6FC79}"/>
+                <a16:creationId xmlns="" xmlns:a16="http://schemas.microsoft.com/office/drawing/2014/main" id="{41A511B0-BA90-A165-AE00-CBE74FF6FC79}"/>
               </a:ext>
             </a:extLst>
           </p:cNvPr>
@@ -3018,7 +3018,7 @@
           <p:cNvPr id="6" name="Slide Number Placeholder 5">
             <a:extLst>
               <a:ext uri="{FF2B5EF4-FFF2-40B4-BE49-F238E27FC236}">
-                <a16:creationId xmlns:a16="http://schemas.microsoft.com/office/drawing/2014/main" xmlns="" id="{17B6AAEB-3C7F-71B3-88D5-D67F0E9B5D5D}"/>
+                <a16:creationId xmlns="" xmlns:a16="http://schemas.microsoft.com/office/drawing/2014/main" id="{17B6AAEB-3C7F-71B3-88D5-D67F0E9B5D5D}"/>
               </a:ext>
             </a:extLst>
           </p:cNvPr>
@@ -3386,7 +3386,7 @@
           <p:cNvPr id="2" name="Title 1">
             <a:extLst>
               <a:ext uri="{FF2B5EF4-FFF2-40B4-BE49-F238E27FC236}">
-                <a16:creationId xmlns:a16="http://schemas.microsoft.com/office/drawing/2014/main" xmlns="" id="{F100A9E6-D168-CC7E-1A39-D7FE4F8604F5}"/>
+                <a16:creationId xmlns="" xmlns:a16="http://schemas.microsoft.com/office/drawing/2014/main" id="{F100A9E6-D168-CC7E-1A39-D7FE4F8604F5}"/>
               </a:ext>
             </a:extLst>
           </p:cNvPr>
@@ -3415,7 +3415,7 @@
           <p:cNvPr id="3" name="Subtitle 2">
             <a:extLst>
               <a:ext uri="{FF2B5EF4-FFF2-40B4-BE49-F238E27FC236}">
-                <a16:creationId xmlns:a16="http://schemas.microsoft.com/office/drawing/2014/main" xmlns="" id="{27D2C30C-196A-58B1-B542-19B9C540A400}"/>
+                <a16:creationId xmlns="" xmlns:a16="http://schemas.microsoft.com/office/drawing/2014/main" id="{27D2C30C-196A-58B1-B542-19B9C540A400}"/>
               </a:ext>
             </a:extLst>
           </p:cNvPr>
@@ -3474,7 +3474,7 @@
           <p:cNvPr id="5" name="Picture 4">
             <a:extLst>
               <a:ext uri="{FF2B5EF4-FFF2-40B4-BE49-F238E27FC236}">
-                <a16:creationId xmlns:a16="http://schemas.microsoft.com/office/drawing/2014/main" xmlns="" id="{E2D4EFE2-9378-67DD-D93D-E0FF52ACAD28}"/>
+                <a16:creationId xmlns="" xmlns:a16="http://schemas.microsoft.com/office/drawing/2014/main" id="{E2D4EFE2-9378-67DD-D93D-E0FF52ACAD28}"/>
               </a:ext>
             </a:extLst>
           </p:cNvPr>
@@ -3504,7 +3504,7 @@
           <p:cNvPr id="8" name="TextBox 7">
             <a:extLst>
               <a:ext uri="{FF2B5EF4-FFF2-40B4-BE49-F238E27FC236}">
-                <a16:creationId xmlns:a16="http://schemas.microsoft.com/office/drawing/2014/main" xmlns="" id="{07FEDF35-0A79-BE33-5A4E-F02C22027EEE}"/>
+                <a16:creationId xmlns="" xmlns:a16="http://schemas.microsoft.com/office/drawing/2014/main" id="{07FEDF35-0A79-BE33-5A4E-F02C22027EEE}"/>
               </a:ext>
             </a:extLst>
           </p:cNvPr>
@@ -3574,7 +3574,7 @@
           <p:cNvPr id="10" name="Picture 9">
             <a:extLst>
               <a:ext uri="{FF2B5EF4-FFF2-40B4-BE49-F238E27FC236}">
-                <a16:creationId xmlns:a16="http://schemas.microsoft.com/office/drawing/2014/main" xmlns="" id="{15F8C631-E6C3-53EE-30BA-FD30ABEDE00C}"/>
+                <a16:creationId xmlns="" xmlns:a16="http://schemas.microsoft.com/office/drawing/2014/main" id="{15F8C631-E6C3-53EE-30BA-FD30ABEDE00C}"/>
               </a:ext>
             </a:extLst>
           </p:cNvPr>
@@ -3614,7 +3614,7 @@
           <p:cNvPr id="12" name="TextBox 11">
             <a:extLst>
               <a:ext uri="{FF2B5EF4-FFF2-40B4-BE49-F238E27FC236}">
-                <a16:creationId xmlns:a16="http://schemas.microsoft.com/office/drawing/2014/main" xmlns="" id="{8076E51C-D2C1-9AF3-0223-F254A6874D19}"/>
+                <a16:creationId xmlns="" xmlns:a16="http://schemas.microsoft.com/office/drawing/2014/main" id="{8076E51C-D2C1-9AF3-0223-F254A6874D19}"/>
               </a:ext>
             </a:extLst>
           </p:cNvPr>
@@ -3688,7 +3688,7 @@
           <p:cNvPr id="5" name="Picture 4">
             <a:extLst>
               <a:ext uri="{FF2B5EF4-FFF2-40B4-BE49-F238E27FC236}">
-                <a16:creationId xmlns:a16="http://schemas.microsoft.com/office/drawing/2014/main" xmlns="" id="{F2726598-3E0A-6FDF-84E2-79CF633E3824}"/>
+                <a16:creationId xmlns="" xmlns:a16="http://schemas.microsoft.com/office/drawing/2014/main" id="{F2726598-3E0A-6FDF-84E2-79CF633E3824}"/>
               </a:ext>
             </a:extLst>
           </p:cNvPr>
@@ -3718,7 +3718,7 @@
           <p:cNvPr id="7" name="Picture 6">
             <a:extLst>
               <a:ext uri="{FF2B5EF4-FFF2-40B4-BE49-F238E27FC236}">
-                <a16:creationId xmlns:a16="http://schemas.microsoft.com/office/drawing/2014/main" xmlns="" id="{EBD5E26B-464C-DE47-3EC7-9105B9074FD5}"/>
+                <a16:creationId xmlns="" xmlns:a16="http://schemas.microsoft.com/office/drawing/2014/main" id="{EBD5E26B-464C-DE47-3EC7-9105B9074FD5}"/>
               </a:ext>
             </a:extLst>
           </p:cNvPr>
@@ -3758,7 +3758,7 @@
           <p:cNvPr id="9" name="TextBox 8">
             <a:extLst>
               <a:ext uri="{FF2B5EF4-FFF2-40B4-BE49-F238E27FC236}">
-                <a16:creationId xmlns:a16="http://schemas.microsoft.com/office/drawing/2014/main" xmlns="" id="{FD0ECB8B-B263-09BE-3257-7C33C5F6B241}"/>
+                <a16:creationId xmlns="" xmlns:a16="http://schemas.microsoft.com/office/drawing/2014/main" id="{FD0ECB8B-B263-09BE-3257-7C33C5F6B241}"/>
               </a:ext>
             </a:extLst>
           </p:cNvPr>
@@ -3823,7 +3823,7 @@
           <p:cNvPr id="5" name="Picture 4">
             <a:extLst>
               <a:ext uri="{FF2B5EF4-FFF2-40B4-BE49-F238E27FC236}">
-                <a16:creationId xmlns:a16="http://schemas.microsoft.com/office/drawing/2014/main" xmlns="" id="{B71C4544-4832-8A92-2EDF-0CB4D1A1A824}"/>
+                <a16:creationId xmlns="" xmlns:a16="http://schemas.microsoft.com/office/drawing/2014/main" id="{B71C4544-4832-8A92-2EDF-0CB4D1A1A824}"/>
               </a:ext>
             </a:extLst>
           </p:cNvPr>
@@ -3863,7 +3863,7 @@
           <p:cNvPr id="7" name="Picture 6">
             <a:extLst>
               <a:ext uri="{FF2B5EF4-FFF2-40B4-BE49-F238E27FC236}">
-                <a16:creationId xmlns:a16="http://schemas.microsoft.com/office/drawing/2014/main" xmlns="" id="{5974D536-D6EB-C32A-56D0-D2A047854FD3}"/>
+                <a16:creationId xmlns="" xmlns:a16="http://schemas.microsoft.com/office/drawing/2014/main" id="{5974D536-D6EB-C32A-56D0-D2A047854FD3}"/>
               </a:ext>
             </a:extLst>
           </p:cNvPr>
@@ -3893,7 +3893,7 @@
           <p:cNvPr id="9" name="TextBox 8">
             <a:extLst>
               <a:ext uri="{FF2B5EF4-FFF2-40B4-BE49-F238E27FC236}">
-                <a16:creationId xmlns:a16="http://schemas.microsoft.com/office/drawing/2014/main" xmlns="" id="{A276F671-0C54-71C8-2822-063F36A0E335}"/>
+                <a16:creationId xmlns="" xmlns:a16="http://schemas.microsoft.com/office/drawing/2014/main" id="{A276F671-0C54-71C8-2822-063F36A0E335}"/>
               </a:ext>
             </a:extLst>
           </p:cNvPr>
@@ -3970,7 +3970,7 @@
           <p:cNvPr id="5" name="TextBox 4">
             <a:extLst>
               <a:ext uri="{FF2B5EF4-FFF2-40B4-BE49-F238E27FC236}">
-                <a16:creationId xmlns:a16="http://schemas.microsoft.com/office/drawing/2014/main" xmlns="" id="{2201DAE5-D4EB-2A07-7EA2-75AF46ADD016}"/>
+                <a16:creationId xmlns="" xmlns:a16="http://schemas.microsoft.com/office/drawing/2014/main" id="{2201DAE5-D4EB-2A07-7EA2-75AF46ADD016}"/>
               </a:ext>
             </a:extLst>
           </p:cNvPr>
@@ -4014,7 +4014,7 @@
           <p:cNvPr id="7" name="Picture 6">
             <a:extLst>
               <a:ext uri="{FF2B5EF4-FFF2-40B4-BE49-F238E27FC236}">
-                <a16:creationId xmlns:a16="http://schemas.microsoft.com/office/drawing/2014/main" xmlns="" id="{90F06CF4-2BFE-C321-E129-B4E03E797FC9}"/>
+                <a16:creationId xmlns="" xmlns:a16="http://schemas.microsoft.com/office/drawing/2014/main" id="{90F06CF4-2BFE-C321-E129-B4E03E797FC9}"/>
               </a:ext>
             </a:extLst>
           </p:cNvPr>
@@ -4054,7 +4054,7 @@
           <p:cNvPr id="9" name="Picture 8">
             <a:extLst>
               <a:ext uri="{FF2B5EF4-FFF2-40B4-BE49-F238E27FC236}">
-                <a16:creationId xmlns:a16="http://schemas.microsoft.com/office/drawing/2014/main" xmlns="" id="{949DB951-6836-D1F7-DD47-30A887294DB0}"/>
+                <a16:creationId xmlns="" xmlns:a16="http://schemas.microsoft.com/office/drawing/2014/main" id="{949DB951-6836-D1F7-DD47-30A887294DB0}"/>
               </a:ext>
             </a:extLst>
           </p:cNvPr>
@@ -4100,7 +4100,7 @@
         <p:cNvPr id="1" name="">
           <a:extLst>
             <a:ext uri="{FF2B5EF4-FFF2-40B4-BE49-F238E27FC236}">
-              <a16:creationId xmlns:a16="http://schemas.microsoft.com/office/drawing/2014/main" xmlns="" id="{F6950C38-9292-B593-7CA0-4EB9A0A407DA}"/>
+              <a16:creationId xmlns="" xmlns:a16="http://schemas.microsoft.com/office/drawing/2014/main" id="{F6950C38-9292-B593-7CA0-4EB9A0A407DA}"/>
             </a:ext>
           </a:extLst>
         </p:cNvPr>
@@ -4120,7 +4120,7 @@
           <p:cNvPr id="3" name="TextBox 2">
             <a:extLst>
               <a:ext uri="{FF2B5EF4-FFF2-40B4-BE49-F238E27FC236}">
-                <a16:creationId xmlns:a16="http://schemas.microsoft.com/office/drawing/2014/main" xmlns="" id="{2462601E-B0A7-1762-C8B9-751F8136F27B}"/>
+                <a16:creationId xmlns="" xmlns:a16="http://schemas.microsoft.com/office/drawing/2014/main" id="{2462601E-B0A7-1762-C8B9-751F8136F27B}"/>
               </a:ext>
             </a:extLst>
           </p:cNvPr>
@@ -4167,7 +4167,7 @@
           <p:cNvPr id="5" name="Picture 4">
             <a:extLst>
               <a:ext uri="{FF2B5EF4-FFF2-40B4-BE49-F238E27FC236}">
-                <a16:creationId xmlns:a16="http://schemas.microsoft.com/office/drawing/2014/main" xmlns="" id="{4CE39D3E-4735-A5D8-332F-8144A7B01C24}"/>
+                <a16:creationId xmlns="" xmlns:a16="http://schemas.microsoft.com/office/drawing/2014/main" id="{4CE39D3E-4735-A5D8-332F-8144A7B01C24}"/>
               </a:ext>
             </a:extLst>
           </p:cNvPr>
@@ -4207,7 +4207,7 @@
           <p:cNvPr id="7" name="Picture 6">
             <a:extLst>
               <a:ext uri="{FF2B5EF4-FFF2-40B4-BE49-F238E27FC236}">
-                <a16:creationId xmlns:a16="http://schemas.microsoft.com/office/drawing/2014/main" xmlns="" id="{1A52C76F-3C9C-527C-EE2A-913BFA78F238}"/>
+                <a16:creationId xmlns="" xmlns:a16="http://schemas.microsoft.com/office/drawing/2014/main" id="{1A52C76F-3C9C-527C-EE2A-913BFA78F238}"/>
               </a:ext>
             </a:extLst>
           </p:cNvPr>
@@ -4237,7 +4237,7 @@
           <p:cNvPr id="9" name="TextBox 8">
             <a:extLst>
               <a:ext uri="{FF2B5EF4-FFF2-40B4-BE49-F238E27FC236}">
-                <a16:creationId xmlns:a16="http://schemas.microsoft.com/office/drawing/2014/main" xmlns="" id="{B71C6BBE-FB7C-4F04-6275-128ECF7AC315}"/>
+                <a16:creationId xmlns="" xmlns:a16="http://schemas.microsoft.com/office/drawing/2014/main" id="{B71C6BBE-FB7C-4F04-6275-128ECF7AC315}"/>
               </a:ext>
             </a:extLst>
           </p:cNvPr>
@@ -4311,7 +4311,7 @@
           <p:cNvPr id="11" name="TextBox 10">
             <a:extLst>
               <a:ext uri="{FF2B5EF4-FFF2-40B4-BE49-F238E27FC236}">
-                <a16:creationId xmlns:a16="http://schemas.microsoft.com/office/drawing/2014/main" xmlns="" id="{1D2BED34-A0DB-70EF-BFE3-AE212DC75215}"/>
+                <a16:creationId xmlns="" xmlns:a16="http://schemas.microsoft.com/office/drawing/2014/main" id="{1D2BED34-A0DB-70EF-BFE3-AE212DC75215}"/>
               </a:ext>
             </a:extLst>
           </p:cNvPr>
@@ -4399,7 +4399,7 @@
         <p:cNvPr id="1" name="">
           <a:extLst>
             <a:ext uri="{FF2B5EF4-FFF2-40B4-BE49-F238E27FC236}">
-              <a16:creationId xmlns:a16="http://schemas.microsoft.com/office/drawing/2014/main" xmlns="" id="{25BB020B-D368-C218-6ADB-FD54930A57A4}"/>
+              <a16:creationId xmlns="" xmlns:a16="http://schemas.microsoft.com/office/drawing/2014/main" id="{25BB020B-D368-C218-6ADB-FD54930A57A4}"/>
             </a:ext>
           </a:extLst>
         </p:cNvPr>
@@ -4419,7 +4419,7 @@
           <p:cNvPr id="3" name="Picture 2">
             <a:extLst>
               <a:ext uri="{FF2B5EF4-FFF2-40B4-BE49-F238E27FC236}">
-                <a16:creationId xmlns:a16="http://schemas.microsoft.com/office/drawing/2014/main" xmlns="" id="{C5B26209-DC4C-7AF3-7D0B-C921976B4752}"/>
+                <a16:creationId xmlns="" xmlns:a16="http://schemas.microsoft.com/office/drawing/2014/main" id="{C5B26209-DC4C-7AF3-7D0B-C921976B4752}"/>
               </a:ext>
             </a:extLst>
           </p:cNvPr>
@@ -4449,7 +4449,7 @@
           <p:cNvPr id="5" name="Picture 4">
             <a:extLst>
               <a:ext uri="{FF2B5EF4-FFF2-40B4-BE49-F238E27FC236}">
-                <a16:creationId xmlns:a16="http://schemas.microsoft.com/office/drawing/2014/main" xmlns="" id="{1950F11D-A982-892D-058A-38A5E484DA0C}"/>
+                <a16:creationId xmlns="" xmlns:a16="http://schemas.microsoft.com/office/drawing/2014/main" id="{1950F11D-A982-892D-058A-38A5E484DA0C}"/>
               </a:ext>
             </a:extLst>
           </p:cNvPr>
@@ -4505,7 +4505,7 @@
         <p:cNvPr id="1" name="">
           <a:extLst>
             <a:ext uri="{FF2B5EF4-FFF2-40B4-BE49-F238E27FC236}">
-              <a16:creationId xmlns:a16="http://schemas.microsoft.com/office/drawing/2014/main" xmlns="" id="{C67C8E01-2F5D-786E-4F07-5DF8BE13196E}"/>
+              <a16:creationId xmlns="" xmlns:a16="http://schemas.microsoft.com/office/drawing/2014/main" id="{C67C8E01-2F5D-786E-4F07-5DF8BE13196E}"/>
             </a:ext>
           </a:extLst>
         </p:cNvPr>
@@ -4525,7 +4525,7 @@
           <p:cNvPr id="2" name="Picture 1">
             <a:extLst>
               <a:ext uri="{FF2B5EF4-FFF2-40B4-BE49-F238E27FC236}">
-                <a16:creationId xmlns:a16="http://schemas.microsoft.com/office/drawing/2014/main" xmlns="" id="{3C253BDC-B679-B345-5E5D-B21C979F3874}"/>
+                <a16:creationId xmlns="" xmlns:a16="http://schemas.microsoft.com/office/drawing/2014/main" id="{3C253BDC-B679-B345-5E5D-B21C979F3874}"/>
               </a:ext>
             </a:extLst>
           </p:cNvPr>
@@ -4555,7 +4555,7 @@
           <p:cNvPr id="4" name="Picture 3">
             <a:extLst>
               <a:ext uri="{FF2B5EF4-FFF2-40B4-BE49-F238E27FC236}">
-                <a16:creationId xmlns:a16="http://schemas.microsoft.com/office/drawing/2014/main" xmlns="" id="{C325CDB2-F28B-200D-075A-C06E3E9FDAC6}"/>
+                <a16:creationId xmlns="" xmlns:a16="http://schemas.microsoft.com/office/drawing/2014/main" id="{C325CDB2-F28B-200D-075A-C06E3E9FDAC6}"/>
               </a:ext>
             </a:extLst>
           </p:cNvPr>
@@ -4625,7 +4625,7 @@
           <p:cNvPr id="5" name="Picture 4">
             <a:extLst>
               <a:ext uri="{FF2B5EF4-FFF2-40B4-BE49-F238E27FC236}">
-                <a16:creationId xmlns:a16="http://schemas.microsoft.com/office/drawing/2014/main" xmlns="" id="{79262430-D11E-A11B-5556-ED7BD7745670}"/>
+                <a16:creationId xmlns="" xmlns:a16="http://schemas.microsoft.com/office/drawing/2014/main" id="{79262430-D11E-A11B-5556-ED7BD7745670}"/>
               </a:ext>
             </a:extLst>
           </p:cNvPr>
@@ -4655,7 +4655,7 @@
           <p:cNvPr id="7" name="Picture 6">
             <a:extLst>
               <a:ext uri="{FF2B5EF4-FFF2-40B4-BE49-F238E27FC236}">
-                <a16:creationId xmlns:a16="http://schemas.microsoft.com/office/drawing/2014/main" xmlns="" id="{D13A723C-FBDF-CD4E-ECB3-D34B162903A8}"/>
+                <a16:creationId xmlns="" xmlns:a16="http://schemas.microsoft.com/office/drawing/2014/main" id="{D13A723C-FBDF-CD4E-ECB3-D34B162903A8}"/>
               </a:ext>
             </a:extLst>
           </p:cNvPr>
@@ -4701,7 +4701,7 @@
         <p:cNvPr id="1" name="">
           <a:extLst>
             <a:ext uri="{FF2B5EF4-FFF2-40B4-BE49-F238E27FC236}">
-              <a16:creationId xmlns:a16="http://schemas.microsoft.com/office/drawing/2014/main" xmlns="" id="{CC719F4B-C956-5034-D0EF-524D7DBEA4B4}"/>
+              <a16:creationId xmlns="" xmlns:a16="http://schemas.microsoft.com/office/drawing/2014/main" id="{CC719F4B-C956-5034-D0EF-524D7DBEA4B4}"/>
             </a:ext>
           </a:extLst>
         </p:cNvPr>
@@ -4721,7 +4721,7 @@
           <p:cNvPr id="3" name="Picture 2">
             <a:extLst>
               <a:ext uri="{FF2B5EF4-FFF2-40B4-BE49-F238E27FC236}">
-                <a16:creationId xmlns:a16="http://schemas.microsoft.com/office/drawing/2014/main" xmlns="" id="{B700A202-2B55-8BCC-82DD-053D06A60C30}"/>
+                <a16:creationId xmlns="" xmlns:a16="http://schemas.microsoft.com/office/drawing/2014/main" id="{B700A202-2B55-8BCC-82DD-053D06A60C30}"/>
               </a:ext>
             </a:extLst>
           </p:cNvPr>
@@ -4751,7 +4751,7 @@
           <p:cNvPr id="6" name="Picture 5">
             <a:extLst>
               <a:ext uri="{FF2B5EF4-FFF2-40B4-BE49-F238E27FC236}">
-                <a16:creationId xmlns:a16="http://schemas.microsoft.com/office/drawing/2014/main" xmlns="" id="{14BFF345-7705-DE88-2160-62E032C00FF8}"/>
+                <a16:creationId xmlns="" xmlns:a16="http://schemas.microsoft.com/office/drawing/2014/main" id="{14BFF345-7705-DE88-2160-62E032C00FF8}"/>
               </a:ext>
             </a:extLst>
           </p:cNvPr>
@@ -4797,7 +4797,7 @@
         <p:cNvPr id="1" name="">
           <a:extLst>
             <a:ext uri="{FF2B5EF4-FFF2-40B4-BE49-F238E27FC236}">
-              <a16:creationId xmlns:a16="http://schemas.microsoft.com/office/drawing/2014/main" xmlns="" id="{7E68A621-3306-1FC7-8860-8A0E4E99F955}"/>
+              <a16:creationId xmlns="" xmlns:a16="http://schemas.microsoft.com/office/drawing/2014/main" id="{7E68A621-3306-1FC7-8860-8A0E4E99F955}"/>
             </a:ext>
           </a:extLst>
         </p:cNvPr>
@@ -4817,7 +4817,7 @@
           <p:cNvPr id="3" name="Picture 2">
             <a:extLst>
               <a:ext uri="{FF2B5EF4-FFF2-40B4-BE49-F238E27FC236}">
-                <a16:creationId xmlns:a16="http://schemas.microsoft.com/office/drawing/2014/main" xmlns="" id="{E24A95B4-5945-8D94-9E11-2C12CC4A1216}"/>
+                <a16:creationId xmlns="" xmlns:a16="http://schemas.microsoft.com/office/drawing/2014/main" id="{E24A95B4-5945-8D94-9E11-2C12CC4A1216}"/>
               </a:ext>
             </a:extLst>
           </p:cNvPr>
@@ -4847,7 +4847,7 @@
           <p:cNvPr id="5" name="Picture 4">
             <a:extLst>
               <a:ext uri="{FF2B5EF4-FFF2-40B4-BE49-F238E27FC236}">
-                <a16:creationId xmlns:a16="http://schemas.microsoft.com/office/drawing/2014/main" xmlns="" id="{F86155D2-CD02-B9D0-FA0B-DB4FE7E86792}"/>
+                <a16:creationId xmlns="" xmlns:a16="http://schemas.microsoft.com/office/drawing/2014/main" id="{F86155D2-CD02-B9D0-FA0B-DB4FE7E86792}"/>
               </a:ext>
             </a:extLst>
           </p:cNvPr>
@@ -4907,7 +4907,7 @@
           <p:cNvPr id="2" name="Title 1">
             <a:extLst>
               <a:ext uri="{FF2B5EF4-FFF2-40B4-BE49-F238E27FC236}">
-                <a16:creationId xmlns:a16="http://schemas.microsoft.com/office/drawing/2014/main" xmlns="" id="{32528164-6122-F8A4-C353-231718BAF1FF}"/>
+                <a16:creationId xmlns="" xmlns:a16="http://schemas.microsoft.com/office/drawing/2014/main" id="{32528164-6122-F8A4-C353-231718BAF1FF}"/>
               </a:ext>
             </a:extLst>
           </p:cNvPr>
@@ -4936,7 +4936,7 @@
           <p:cNvPr id="3" name="Content Placeholder 2">
             <a:extLst>
               <a:ext uri="{FF2B5EF4-FFF2-40B4-BE49-F238E27FC236}">
-                <a16:creationId xmlns:a16="http://schemas.microsoft.com/office/drawing/2014/main" xmlns="" id="{F0A51C1B-91BC-F8C3-47BF-AA0BCD30D973}"/>
+                <a16:creationId xmlns="" xmlns:a16="http://schemas.microsoft.com/office/drawing/2014/main" id="{F0A51C1B-91BC-F8C3-47BF-AA0BCD30D973}"/>
               </a:ext>
             </a:extLst>
           </p:cNvPr>
@@ -5372,7 +5372,7 @@
         <p:cNvPr id="1" name="">
           <a:extLst>
             <a:ext uri="{FF2B5EF4-FFF2-40B4-BE49-F238E27FC236}">
-              <a16:creationId xmlns:a16="http://schemas.microsoft.com/office/drawing/2014/main" xmlns="" id="{8F34D19B-48CC-EF30-A92A-4D5F13ACC2ED}"/>
+              <a16:creationId xmlns="" xmlns:a16="http://schemas.microsoft.com/office/drawing/2014/main" id="{8F34D19B-48CC-EF30-A92A-4D5F13ACC2ED}"/>
             </a:ext>
           </a:extLst>
         </p:cNvPr>
@@ -5392,7 +5392,7 @@
           <p:cNvPr id="3" name="Picture 2">
             <a:extLst>
               <a:ext uri="{FF2B5EF4-FFF2-40B4-BE49-F238E27FC236}">
-                <a16:creationId xmlns:a16="http://schemas.microsoft.com/office/drawing/2014/main" xmlns="" id="{8EBC7A8E-79F6-1406-9512-8002FFABFD7C}"/>
+                <a16:creationId xmlns="" xmlns:a16="http://schemas.microsoft.com/office/drawing/2014/main" id="{8EBC7A8E-79F6-1406-9512-8002FFABFD7C}"/>
               </a:ext>
             </a:extLst>
           </p:cNvPr>
@@ -5422,7 +5422,7 @@
           <p:cNvPr id="5" name="Picture 4">
             <a:extLst>
               <a:ext uri="{FF2B5EF4-FFF2-40B4-BE49-F238E27FC236}">
-                <a16:creationId xmlns:a16="http://schemas.microsoft.com/office/drawing/2014/main" xmlns="" id="{9AE0C104-871D-31D8-F2CF-A1C45B151D4D}"/>
+                <a16:creationId xmlns="" xmlns:a16="http://schemas.microsoft.com/office/drawing/2014/main" id="{9AE0C104-871D-31D8-F2CF-A1C45B151D4D}"/>
               </a:ext>
             </a:extLst>
           </p:cNvPr>
@@ -5468,7 +5468,7 @@
         <p:cNvPr id="1" name="">
           <a:extLst>
             <a:ext uri="{FF2B5EF4-FFF2-40B4-BE49-F238E27FC236}">
-              <a16:creationId xmlns:a16="http://schemas.microsoft.com/office/drawing/2014/main" xmlns="" id="{5053939B-B420-F058-8FE6-A281BCDACD8C}"/>
+              <a16:creationId xmlns="" xmlns:a16="http://schemas.microsoft.com/office/drawing/2014/main" id="{5053939B-B420-F058-8FE6-A281BCDACD8C}"/>
             </a:ext>
           </a:extLst>
         </p:cNvPr>
@@ -5488,7 +5488,7 @@
           <p:cNvPr id="5" name="Picture 4">
             <a:extLst>
               <a:ext uri="{FF2B5EF4-FFF2-40B4-BE49-F238E27FC236}">
-                <a16:creationId xmlns:a16="http://schemas.microsoft.com/office/drawing/2014/main" xmlns="" id="{6700BCD4-E3AC-4A9A-25BE-7EBDAC40A9DE}"/>
+                <a16:creationId xmlns="" xmlns:a16="http://schemas.microsoft.com/office/drawing/2014/main" id="{6700BCD4-E3AC-4A9A-25BE-7EBDAC40A9DE}"/>
               </a:ext>
             </a:extLst>
           </p:cNvPr>
@@ -5518,7 +5518,7 @@
           <p:cNvPr id="6" name="Picture 5">
             <a:extLst>
               <a:ext uri="{FF2B5EF4-FFF2-40B4-BE49-F238E27FC236}">
-                <a16:creationId xmlns:a16="http://schemas.microsoft.com/office/drawing/2014/main" xmlns="" id="{A8633CF4-D512-AF05-464D-0D31D233DC14}"/>
+                <a16:creationId xmlns="" xmlns:a16="http://schemas.microsoft.com/office/drawing/2014/main" id="{A8633CF4-D512-AF05-464D-0D31D233DC14}"/>
               </a:ext>
             </a:extLst>
           </p:cNvPr>
@@ -5564,7 +5564,7 @@
         <p:cNvPr id="1" name="">
           <a:extLst>
             <a:ext uri="{FF2B5EF4-FFF2-40B4-BE49-F238E27FC236}">
-              <a16:creationId xmlns:a16="http://schemas.microsoft.com/office/drawing/2014/main" xmlns="" id="{BFEF1E00-25BA-83A7-37FE-22E0DC8EF054}"/>
+              <a16:creationId xmlns="" xmlns:a16="http://schemas.microsoft.com/office/drawing/2014/main" id="{BFEF1E00-25BA-83A7-37FE-22E0DC8EF054}"/>
             </a:ext>
           </a:extLst>
         </p:cNvPr>
@@ -5584,7 +5584,7 @@
           <p:cNvPr id="3" name="TextBox 2">
             <a:extLst>
               <a:ext uri="{FF2B5EF4-FFF2-40B4-BE49-F238E27FC236}">
-                <a16:creationId xmlns:a16="http://schemas.microsoft.com/office/drawing/2014/main" xmlns="" id="{F894366E-A2D2-670B-884C-9ECC7AF1277C}"/>
+                <a16:creationId xmlns="" xmlns:a16="http://schemas.microsoft.com/office/drawing/2014/main" id="{F894366E-A2D2-670B-884C-9ECC7AF1277C}"/>
               </a:ext>
             </a:extLst>
           </p:cNvPr>
@@ -5650,7 +5650,7 @@
           <p:cNvPr id="5" name="TextBox 4">
             <a:extLst>
               <a:ext uri="{FF2B5EF4-FFF2-40B4-BE49-F238E27FC236}">
-                <a16:creationId xmlns:a16="http://schemas.microsoft.com/office/drawing/2014/main" xmlns="" id="{FFAC8043-6EA7-11CD-57B7-4D0F623EBBE6}"/>
+                <a16:creationId xmlns="" xmlns:a16="http://schemas.microsoft.com/office/drawing/2014/main" id="{FFAC8043-6EA7-11CD-57B7-4D0F623EBBE6}"/>
               </a:ext>
             </a:extLst>
           </p:cNvPr>
@@ -5691,7 +5691,7 @@
           <p:cNvPr id="7" name="Picture 6">
             <a:extLst>
               <a:ext uri="{FF2B5EF4-FFF2-40B4-BE49-F238E27FC236}">
-                <a16:creationId xmlns:a16="http://schemas.microsoft.com/office/drawing/2014/main" xmlns="" id="{D7F9D23E-34D3-D7FA-410D-69DE2BABD60B}"/>
+                <a16:creationId xmlns="" xmlns:a16="http://schemas.microsoft.com/office/drawing/2014/main" id="{D7F9D23E-34D3-D7FA-410D-69DE2BABD60B}"/>
               </a:ext>
             </a:extLst>
           </p:cNvPr>
@@ -5721,7 +5721,7 @@
           <p:cNvPr id="8" name="TextBox 7">
             <a:extLst>
               <a:ext uri="{FF2B5EF4-FFF2-40B4-BE49-F238E27FC236}">
-                <a16:creationId xmlns:a16="http://schemas.microsoft.com/office/drawing/2014/main" xmlns="" id="{2CF7415C-0E73-4EC3-73DC-99B88BEB0D54}"/>
+                <a16:creationId xmlns="" xmlns:a16="http://schemas.microsoft.com/office/drawing/2014/main" id="{2CF7415C-0E73-4EC3-73DC-99B88BEB0D54}"/>
               </a:ext>
             </a:extLst>
           </p:cNvPr>
@@ -5731,7 +5731,7 @@
         <p:spPr>
           <a:xfrm>
             <a:off x="7554799" y="1476022"/>
-            <a:ext cx="3483988" cy="646331"/>
+            <a:ext cx="3483988" cy="5078313"/>
           </a:xfrm>
           <a:prstGeom prst="rect">
             <a:avLst/>
@@ -5753,9 +5753,205 @@
               <a:t> </a:t>
             </a:r>
             <a:r>
-              <a:rPr lang="en-GB" dirty="0" err="1"/>
+              <a:rPr lang="en-GB" dirty="0" err="1" smtClean="0"/>
               <a:t>calea</a:t>
             </a:r>
+            <a:endParaRPr lang="en-GB" dirty="0" smtClean="0"/>
+          </a:p>
+          <a:p>
+            <a:endParaRPr lang="en-GB" dirty="0"/>
+          </a:p>
+          <a:p>
+            <a:pPr marL="342900" indent="-342900">
+              <a:buAutoNum type="arabicPeriod"/>
+            </a:pPr>
+            <a:r>
+              <a:rPr lang="en-GB" dirty="0" err="1" smtClean="0"/>
+              <a:t>Adaugam</a:t>
+            </a:r>
+            <a:r>
+              <a:rPr lang="en-GB" dirty="0" smtClean="0"/>
+              <a:t> o a </a:t>
+            </a:r>
+            <a:r>
+              <a:rPr lang="en-GB" dirty="0" err="1" smtClean="0"/>
+              <a:t>doua</a:t>
+            </a:r>
+            <a:r>
+              <a:rPr lang="en-GB" dirty="0" smtClean="0"/>
+              <a:t> </a:t>
+            </a:r>
+            <a:r>
+              <a:rPr lang="en-GB" dirty="0" err="1" smtClean="0"/>
+              <a:t>coloana</a:t>
+            </a:r>
+            <a:r>
+              <a:rPr lang="en-GB" dirty="0" smtClean="0"/>
+              <a:t>, “Target” </a:t>
+            </a:r>
+            <a:r>
+              <a:rPr lang="en-GB" dirty="0" err="1" smtClean="0"/>
+              <a:t>si</a:t>
+            </a:r>
+            <a:r>
+              <a:rPr lang="en-GB" dirty="0" smtClean="0"/>
+              <a:t> </a:t>
+            </a:r>
+            <a:r>
+              <a:rPr lang="en-GB" dirty="0" err="1" smtClean="0"/>
+              <a:t>inseram</a:t>
+            </a:r>
+            <a:r>
+              <a:rPr lang="en-GB" dirty="0" smtClean="0"/>
+              <a:t> </a:t>
+            </a:r>
+            <a:r>
+              <a:rPr lang="en-GB" dirty="0" err="1" smtClean="0"/>
+              <a:t>numere</a:t>
+            </a:r>
+            <a:r>
+              <a:rPr lang="en-GB" dirty="0" smtClean="0"/>
+              <a:t> </a:t>
+            </a:r>
+            <a:r>
+              <a:rPr lang="en-GB" dirty="0" err="1" smtClean="0"/>
+              <a:t>aleatorii</a:t>
+            </a:r>
+            <a:r>
+              <a:rPr lang="en-GB" dirty="0" smtClean="0"/>
+              <a:t>.</a:t>
+            </a:r>
+          </a:p>
+          <a:p>
+            <a:pPr marL="342900" indent="-342900">
+              <a:buAutoNum type="arabicPeriod"/>
+            </a:pPr>
+            <a:r>
+              <a:rPr lang="en-GB" dirty="0" err="1" smtClean="0"/>
+              <a:t>Folositi</a:t>
+            </a:r>
+            <a:r>
+              <a:rPr lang="en-GB" smtClean="0"/>
+              <a:t> Spectral </a:t>
+            </a:r>
+            <a:r>
+              <a:rPr lang="en-GB" dirty="0" smtClean="0"/>
+              <a:t>Forecast. </a:t>
+            </a:r>
+            <a:r>
+              <a:rPr lang="en-GB" dirty="0" err="1" smtClean="0"/>
+              <a:t>Semnalul</a:t>
+            </a:r>
+            <a:r>
+              <a:rPr lang="en-GB" dirty="0" smtClean="0"/>
+              <a:t> A </a:t>
+            </a:r>
+            <a:r>
+              <a:rPr lang="en-GB" dirty="0" err="1" smtClean="0"/>
+              <a:t>va</a:t>
+            </a:r>
+            <a:r>
+              <a:rPr lang="en-GB" dirty="0" smtClean="0"/>
+              <a:t> fi </a:t>
+            </a:r>
+            <a:r>
+              <a:rPr lang="en-GB" dirty="0" err="1" smtClean="0"/>
+              <a:t>reprezentat</a:t>
+            </a:r>
+            <a:r>
+              <a:rPr lang="en-GB" dirty="0" smtClean="0"/>
+              <a:t> de </a:t>
+            </a:r>
+            <a:r>
+              <a:rPr lang="en-GB" dirty="0" err="1" smtClean="0"/>
+              <a:t>coloana</a:t>
+            </a:r>
+            <a:r>
+              <a:rPr lang="en-GB" dirty="0" smtClean="0"/>
+              <a:t> “</a:t>
+            </a:r>
+            <a:r>
+              <a:rPr lang="en-GB" dirty="0" err="1" smtClean="0"/>
+              <a:t>Vanzari</a:t>
+            </a:r>
+            <a:r>
+              <a:rPr lang="en-GB" dirty="0" smtClean="0"/>
+              <a:t>” </a:t>
+            </a:r>
+            <a:r>
+              <a:rPr lang="en-GB" dirty="0" err="1" smtClean="0"/>
+              <a:t>iar</a:t>
+            </a:r>
+            <a:r>
+              <a:rPr lang="en-GB" dirty="0" smtClean="0"/>
+              <a:t> </a:t>
+            </a:r>
+            <a:r>
+              <a:rPr lang="en-GB" dirty="0" err="1" smtClean="0"/>
+              <a:t>semnalul</a:t>
+            </a:r>
+            <a:r>
+              <a:rPr lang="en-GB" dirty="0" smtClean="0"/>
+              <a:t> B </a:t>
+            </a:r>
+            <a:r>
+              <a:rPr lang="en-GB" dirty="0" err="1" smtClean="0"/>
+              <a:t>va</a:t>
+            </a:r>
+            <a:r>
+              <a:rPr lang="en-GB" dirty="0" smtClean="0"/>
+              <a:t> fi </a:t>
+            </a:r>
+            <a:r>
+              <a:rPr lang="en-GB" dirty="0" err="1" smtClean="0"/>
+              <a:t>reprezentat</a:t>
+            </a:r>
+            <a:r>
+              <a:rPr lang="en-GB" dirty="0" smtClean="0"/>
+              <a:t> de </a:t>
+            </a:r>
+            <a:r>
+              <a:rPr lang="en-GB" dirty="0" err="1" smtClean="0"/>
+              <a:t>coloana</a:t>
+            </a:r>
+            <a:r>
+              <a:rPr lang="en-GB" dirty="0" smtClean="0"/>
+              <a:t> “Target”.</a:t>
+            </a:r>
+          </a:p>
+          <a:p>
+            <a:pPr marL="342900" indent="-342900">
+              <a:buAutoNum type="arabicPeriod"/>
+            </a:pPr>
+            <a:r>
+              <a:rPr lang="en-GB" dirty="0" err="1" smtClean="0"/>
+              <a:t>Plotati</a:t>
+            </a:r>
+            <a:r>
+              <a:rPr lang="en-GB" dirty="0" smtClean="0"/>
+              <a:t> </a:t>
+            </a:r>
+            <a:r>
+              <a:rPr lang="en-GB" dirty="0" err="1" smtClean="0"/>
+              <a:t>semnalul</a:t>
+            </a:r>
+            <a:r>
+              <a:rPr lang="en-GB" dirty="0" smtClean="0"/>
+              <a:t> M </a:t>
+            </a:r>
+            <a:r>
+              <a:rPr lang="en-GB" dirty="0" err="1" smtClean="0"/>
+              <a:t>pentru</a:t>
+            </a:r>
+            <a:r>
+              <a:rPr lang="en-GB" dirty="0" smtClean="0"/>
+              <a:t> d = 50.</a:t>
+            </a:r>
+          </a:p>
+          <a:p>
+            <a:endParaRPr lang="en-GB" dirty="0"/>
+          </a:p>
+          <a:p>
             <a:endParaRPr lang="en-GB" dirty="0"/>
           </a:p>
           <a:p>
@@ -5784,7 +5980,7 @@
         <p:cNvPr id="1" name="">
           <a:extLst>
             <a:ext uri="{FF2B5EF4-FFF2-40B4-BE49-F238E27FC236}">
-              <a16:creationId xmlns:a16="http://schemas.microsoft.com/office/drawing/2014/main" xmlns="" id="{7298BF5E-4CD8-DEA6-14D9-F7B9B22C360D}"/>
+              <a16:creationId xmlns="" xmlns:a16="http://schemas.microsoft.com/office/drawing/2014/main" id="{7298BF5E-4CD8-DEA6-14D9-F7B9B22C360D}"/>
             </a:ext>
           </a:extLst>
         </p:cNvPr>
@@ -5804,7 +6000,7 @@
           <p:cNvPr id="3" name="Picture 2">
             <a:extLst>
               <a:ext uri="{FF2B5EF4-FFF2-40B4-BE49-F238E27FC236}">
-                <a16:creationId xmlns:a16="http://schemas.microsoft.com/office/drawing/2014/main" xmlns="" id="{36102D40-169A-11FB-3AA6-2EB761CDC311}"/>
+                <a16:creationId xmlns="" xmlns:a16="http://schemas.microsoft.com/office/drawing/2014/main" id="{36102D40-169A-11FB-3AA6-2EB761CDC311}"/>
               </a:ext>
             </a:extLst>
           </p:cNvPr>
@@ -5834,7 +6030,7 @@
           <p:cNvPr id="5" name="Picture 4">
             <a:extLst>
               <a:ext uri="{FF2B5EF4-FFF2-40B4-BE49-F238E27FC236}">
-                <a16:creationId xmlns:a16="http://schemas.microsoft.com/office/drawing/2014/main" xmlns="" id="{019F40AD-2FE3-B453-5EB4-5937A23796D2}"/>
+                <a16:creationId xmlns="" xmlns:a16="http://schemas.microsoft.com/office/drawing/2014/main" id="{019F40AD-2FE3-B453-5EB4-5937A23796D2}"/>
               </a:ext>
             </a:extLst>
           </p:cNvPr>
@@ -5880,7 +6076,7 @@
         <p:cNvPr id="1" name="">
           <a:extLst>
             <a:ext uri="{FF2B5EF4-FFF2-40B4-BE49-F238E27FC236}">
-              <a16:creationId xmlns:a16="http://schemas.microsoft.com/office/drawing/2014/main" xmlns="" id="{47BA02F3-625F-F445-71F7-9C9AE7929870}"/>
+              <a16:creationId xmlns="" xmlns:a16="http://schemas.microsoft.com/office/drawing/2014/main" id="{47BA02F3-625F-F445-71F7-9C9AE7929870}"/>
             </a:ext>
           </a:extLst>
         </p:cNvPr>
@@ -5916,7 +6112,7 @@
         <p:cNvPr id="1" name="">
           <a:extLst>
             <a:ext uri="{FF2B5EF4-FFF2-40B4-BE49-F238E27FC236}">
-              <a16:creationId xmlns:a16="http://schemas.microsoft.com/office/drawing/2014/main" xmlns="" id="{FFB5A3F7-F79D-49C8-34CE-2E578D4908A8}"/>
+              <a16:creationId xmlns="" xmlns:a16="http://schemas.microsoft.com/office/drawing/2014/main" id="{FFB5A3F7-F79D-49C8-34CE-2E578D4908A8}"/>
             </a:ext>
           </a:extLst>
         </p:cNvPr>
@@ -5952,7 +6148,7 @@
         <p:cNvPr id="1" name="">
           <a:extLst>
             <a:ext uri="{FF2B5EF4-FFF2-40B4-BE49-F238E27FC236}">
-              <a16:creationId xmlns:a16="http://schemas.microsoft.com/office/drawing/2014/main" xmlns="" id="{42EA55E1-4C9E-9DA6-A113-0B1730C7EC23}"/>
+              <a16:creationId xmlns="" xmlns:a16="http://schemas.microsoft.com/office/drawing/2014/main" id="{42EA55E1-4C9E-9DA6-A113-0B1730C7EC23}"/>
             </a:ext>
           </a:extLst>
         </p:cNvPr>
@@ -5988,7 +6184,7 @@
         <p:cNvPr id="1" name="">
           <a:extLst>
             <a:ext uri="{FF2B5EF4-FFF2-40B4-BE49-F238E27FC236}">
-              <a16:creationId xmlns:a16="http://schemas.microsoft.com/office/drawing/2014/main" xmlns="" id="{645D06A2-0498-01CD-D9BB-0CF2D874C1DE}"/>
+              <a16:creationId xmlns="" xmlns:a16="http://schemas.microsoft.com/office/drawing/2014/main" id="{645D06A2-0498-01CD-D9BB-0CF2D874C1DE}"/>
             </a:ext>
           </a:extLst>
         </p:cNvPr>
@@ -6024,7 +6220,7 @@
         <p:cNvPr id="1" name="">
           <a:extLst>
             <a:ext uri="{FF2B5EF4-FFF2-40B4-BE49-F238E27FC236}">
-              <a16:creationId xmlns:a16="http://schemas.microsoft.com/office/drawing/2014/main" xmlns="" id="{7D1B02D9-20ED-E4FC-71A1-F47C5D6A1C41}"/>
+              <a16:creationId xmlns="" xmlns:a16="http://schemas.microsoft.com/office/drawing/2014/main" id="{7D1B02D9-20ED-E4FC-71A1-F47C5D6A1C41}"/>
             </a:ext>
           </a:extLst>
         </p:cNvPr>
@@ -6060,7 +6256,7 @@
         <p:cNvPr id="1" name="">
           <a:extLst>
             <a:ext uri="{FF2B5EF4-FFF2-40B4-BE49-F238E27FC236}">
-              <a16:creationId xmlns:a16="http://schemas.microsoft.com/office/drawing/2014/main" xmlns="" id="{1DCBDFEE-04C0-969A-18FF-575AF5FAEC4E}"/>
+              <a16:creationId xmlns="" xmlns:a16="http://schemas.microsoft.com/office/drawing/2014/main" id="{1DCBDFEE-04C0-969A-18FF-575AF5FAEC4E}"/>
             </a:ext>
           </a:extLst>
         </p:cNvPr>
@@ -6110,7 +6306,7 @@
           <p:cNvPr id="5" name="Picture 4">
             <a:extLst>
               <a:ext uri="{FF2B5EF4-FFF2-40B4-BE49-F238E27FC236}">
-                <a16:creationId xmlns:a16="http://schemas.microsoft.com/office/drawing/2014/main" xmlns="" id="{C68D7D26-B5C4-60E4-180B-DF2B8E9951FB}"/>
+                <a16:creationId xmlns="" xmlns:a16="http://schemas.microsoft.com/office/drawing/2014/main" id="{C68D7D26-B5C4-60E4-180B-DF2B8E9951FB}"/>
               </a:ext>
             </a:extLst>
           </p:cNvPr>
@@ -6140,7 +6336,7 @@
           <p:cNvPr id="7" name="Picture 6">
             <a:extLst>
               <a:ext uri="{FF2B5EF4-FFF2-40B4-BE49-F238E27FC236}">
-                <a16:creationId xmlns:a16="http://schemas.microsoft.com/office/drawing/2014/main" xmlns="" id="{44B43F0B-45C1-D17A-8B96-F08415C87C9E}"/>
+                <a16:creationId xmlns="" xmlns:a16="http://schemas.microsoft.com/office/drawing/2014/main" id="{44B43F0B-45C1-D17A-8B96-F08415C87C9E}"/>
               </a:ext>
             </a:extLst>
           </p:cNvPr>
@@ -6170,7 +6366,7 @@
           <p:cNvPr id="9" name="TextBox 8">
             <a:extLst>
               <a:ext uri="{FF2B5EF4-FFF2-40B4-BE49-F238E27FC236}">
-                <a16:creationId xmlns:a16="http://schemas.microsoft.com/office/drawing/2014/main" xmlns="" id="{8EC35B07-F43D-D0CA-44D2-3E7F6817CE6A}"/>
+                <a16:creationId xmlns="" xmlns:a16="http://schemas.microsoft.com/office/drawing/2014/main" id="{8EC35B07-F43D-D0CA-44D2-3E7F6817CE6A}"/>
               </a:ext>
             </a:extLst>
           </p:cNvPr>
@@ -6225,7 +6421,7 @@
         <p:cNvPr id="1" name="">
           <a:extLst>
             <a:ext uri="{FF2B5EF4-FFF2-40B4-BE49-F238E27FC236}">
-              <a16:creationId xmlns:a16="http://schemas.microsoft.com/office/drawing/2014/main" xmlns="" id="{C30918AE-518C-AA83-1CEE-5DFC5001362E}"/>
+              <a16:creationId xmlns="" xmlns:a16="http://schemas.microsoft.com/office/drawing/2014/main" id="{C30918AE-518C-AA83-1CEE-5DFC5001362E}"/>
             </a:ext>
           </a:extLst>
         </p:cNvPr>
@@ -6261,7 +6457,7 @@
         <p:cNvPr id="1" name="">
           <a:extLst>
             <a:ext uri="{FF2B5EF4-FFF2-40B4-BE49-F238E27FC236}">
-              <a16:creationId xmlns:a16="http://schemas.microsoft.com/office/drawing/2014/main" xmlns="" id="{A45B2CEF-AB24-FEF8-C70C-1E86E1019B28}"/>
+              <a16:creationId xmlns="" xmlns:a16="http://schemas.microsoft.com/office/drawing/2014/main" id="{A45B2CEF-AB24-FEF8-C70C-1E86E1019B28}"/>
             </a:ext>
           </a:extLst>
         </p:cNvPr>
@@ -6297,7 +6493,7 @@
         <p:cNvPr id="1" name="">
           <a:extLst>
             <a:ext uri="{FF2B5EF4-FFF2-40B4-BE49-F238E27FC236}">
-              <a16:creationId xmlns:a16="http://schemas.microsoft.com/office/drawing/2014/main" xmlns="" id="{C70E265B-430E-877D-7895-B23D07D171B0}"/>
+              <a16:creationId xmlns="" xmlns:a16="http://schemas.microsoft.com/office/drawing/2014/main" id="{C70E265B-430E-877D-7895-B23D07D171B0}"/>
             </a:ext>
           </a:extLst>
         </p:cNvPr>
@@ -6333,7 +6529,7 @@
         <p:cNvPr id="1" name="">
           <a:extLst>
             <a:ext uri="{FF2B5EF4-FFF2-40B4-BE49-F238E27FC236}">
-              <a16:creationId xmlns:a16="http://schemas.microsoft.com/office/drawing/2014/main" xmlns="" id="{78BE4AFE-DA00-7B4C-8160-55AFEF7B77F7}"/>
+              <a16:creationId xmlns="" xmlns:a16="http://schemas.microsoft.com/office/drawing/2014/main" id="{78BE4AFE-DA00-7B4C-8160-55AFEF7B77F7}"/>
             </a:ext>
           </a:extLst>
         </p:cNvPr>
@@ -6369,7 +6565,7 @@
         <p:cNvPr id="1" name="">
           <a:extLst>
             <a:ext uri="{FF2B5EF4-FFF2-40B4-BE49-F238E27FC236}">
-              <a16:creationId xmlns:a16="http://schemas.microsoft.com/office/drawing/2014/main" xmlns="" id="{89B67E1D-E354-21AA-F02D-77B19F30DC03}"/>
+              <a16:creationId xmlns="" xmlns:a16="http://schemas.microsoft.com/office/drawing/2014/main" id="{89B67E1D-E354-21AA-F02D-77B19F30DC03}"/>
             </a:ext>
           </a:extLst>
         </p:cNvPr>
@@ -6405,7 +6601,7 @@
         <p:cNvPr id="1" name="">
           <a:extLst>
             <a:ext uri="{FF2B5EF4-FFF2-40B4-BE49-F238E27FC236}">
-              <a16:creationId xmlns:a16="http://schemas.microsoft.com/office/drawing/2014/main" xmlns="" id="{67C5D7FC-A1A2-F76A-98AC-0C2F422B46D0}"/>
+              <a16:creationId xmlns="" xmlns:a16="http://schemas.microsoft.com/office/drawing/2014/main" id="{67C5D7FC-A1A2-F76A-98AC-0C2F422B46D0}"/>
             </a:ext>
           </a:extLst>
         </p:cNvPr>
@@ -6455,7 +6651,7 @@
           <p:cNvPr id="5" name="TextBox 4">
             <a:extLst>
               <a:ext uri="{FF2B5EF4-FFF2-40B4-BE49-F238E27FC236}">
-                <a16:creationId xmlns:a16="http://schemas.microsoft.com/office/drawing/2014/main" xmlns="" id="{957338D1-DA3E-465A-7428-666B3EC72F12}"/>
+                <a16:creationId xmlns="" xmlns:a16="http://schemas.microsoft.com/office/drawing/2014/main" id="{957338D1-DA3E-465A-7428-666B3EC72F12}"/>
               </a:ext>
             </a:extLst>
           </p:cNvPr>
@@ -6494,7 +6690,7 @@
           <p:cNvPr id="7" name="Picture 6">
             <a:extLst>
               <a:ext uri="{FF2B5EF4-FFF2-40B4-BE49-F238E27FC236}">
-                <a16:creationId xmlns:a16="http://schemas.microsoft.com/office/drawing/2014/main" xmlns="" id="{6FD3D8A3-5DD4-2FA4-DF69-2E61B62DE29D}"/>
+                <a16:creationId xmlns="" xmlns:a16="http://schemas.microsoft.com/office/drawing/2014/main" id="{6FD3D8A3-5DD4-2FA4-DF69-2E61B62DE29D}"/>
               </a:ext>
             </a:extLst>
           </p:cNvPr>
@@ -6554,7 +6750,7 @@
           <p:cNvPr id="5" name="Picture 4">
             <a:extLst>
               <a:ext uri="{FF2B5EF4-FFF2-40B4-BE49-F238E27FC236}">
-                <a16:creationId xmlns:a16="http://schemas.microsoft.com/office/drawing/2014/main" xmlns="" id="{DF141C6D-47E5-7F16-EE9E-7D6059336B37}"/>
+                <a16:creationId xmlns="" xmlns:a16="http://schemas.microsoft.com/office/drawing/2014/main" id="{DF141C6D-47E5-7F16-EE9E-7D6059336B37}"/>
               </a:ext>
             </a:extLst>
           </p:cNvPr>
@@ -6584,7 +6780,7 @@
           <p:cNvPr id="7" name="TextBox 6">
             <a:extLst>
               <a:ext uri="{FF2B5EF4-FFF2-40B4-BE49-F238E27FC236}">
-                <a16:creationId xmlns:a16="http://schemas.microsoft.com/office/drawing/2014/main" xmlns="" id="{CE07B159-7E2A-C876-5D08-D9ECE3A4A6A6}"/>
+                <a16:creationId xmlns="" xmlns:a16="http://schemas.microsoft.com/office/drawing/2014/main" id="{CE07B159-7E2A-C876-5D08-D9ECE3A4A6A6}"/>
               </a:ext>
             </a:extLst>
           </p:cNvPr>
@@ -6669,7 +6865,7 @@
           <p:cNvPr id="5" name="TextBox 4">
             <a:extLst>
               <a:ext uri="{FF2B5EF4-FFF2-40B4-BE49-F238E27FC236}">
-                <a16:creationId xmlns:a16="http://schemas.microsoft.com/office/drawing/2014/main" xmlns="" id="{0FECE008-19AB-5D4E-6C97-A80D0BD63EC7}"/>
+                <a16:creationId xmlns="" xmlns:a16="http://schemas.microsoft.com/office/drawing/2014/main" id="{0FECE008-19AB-5D4E-6C97-A80D0BD63EC7}"/>
               </a:ext>
             </a:extLst>
           </p:cNvPr>
@@ -6744,7 +6940,7 @@
           <p:cNvPr id="7" name="Picture 6">
             <a:extLst>
               <a:ext uri="{FF2B5EF4-FFF2-40B4-BE49-F238E27FC236}">
-                <a16:creationId xmlns:a16="http://schemas.microsoft.com/office/drawing/2014/main" xmlns="" id="{027DB7FC-C084-C6EE-D940-D0FB8ADE526C}"/>
+                <a16:creationId xmlns="" xmlns:a16="http://schemas.microsoft.com/office/drawing/2014/main" id="{027DB7FC-C084-C6EE-D940-D0FB8ADE526C}"/>
               </a:ext>
             </a:extLst>
           </p:cNvPr>
@@ -6774,7 +6970,7 @@
           <p:cNvPr id="9" name="Picture 8">
             <a:extLst>
               <a:ext uri="{FF2B5EF4-FFF2-40B4-BE49-F238E27FC236}">
-                <a16:creationId xmlns:a16="http://schemas.microsoft.com/office/drawing/2014/main" xmlns="" id="{095EF9D6-5CDC-BE38-AD03-4AEB02D07022}"/>
+                <a16:creationId xmlns="" xmlns:a16="http://schemas.microsoft.com/office/drawing/2014/main" id="{095EF9D6-5CDC-BE38-AD03-4AEB02D07022}"/>
               </a:ext>
             </a:extLst>
           </p:cNvPr>
@@ -6804,7 +7000,7 @@
           <p:cNvPr id="11" name="TextBox 10">
             <a:extLst>
               <a:ext uri="{FF2B5EF4-FFF2-40B4-BE49-F238E27FC236}">
-                <a16:creationId xmlns:a16="http://schemas.microsoft.com/office/drawing/2014/main" xmlns="" id="{40B60CAF-754E-133A-EBAC-1AF907325D7C}"/>
+                <a16:creationId xmlns="" xmlns:a16="http://schemas.microsoft.com/office/drawing/2014/main" id="{40B60CAF-754E-133A-EBAC-1AF907325D7C}"/>
               </a:ext>
             </a:extLst>
           </p:cNvPr>
@@ -6839,7 +7035,7 @@
           <p:cNvPr id="13" name="TextBox 12">
             <a:extLst>
               <a:ext uri="{FF2B5EF4-FFF2-40B4-BE49-F238E27FC236}">
-                <a16:creationId xmlns:a16="http://schemas.microsoft.com/office/drawing/2014/main" xmlns="" id="{785F32E8-4725-A17E-214D-F2E6EBA16A53}"/>
+                <a16:creationId xmlns="" xmlns:a16="http://schemas.microsoft.com/office/drawing/2014/main" id="{785F32E8-4725-A17E-214D-F2E6EBA16A53}"/>
               </a:ext>
             </a:extLst>
           </p:cNvPr>
@@ -6918,7 +7114,7 @@
           <p:cNvPr id="5" name="Picture 4">
             <a:extLst>
               <a:ext uri="{FF2B5EF4-FFF2-40B4-BE49-F238E27FC236}">
-                <a16:creationId xmlns:a16="http://schemas.microsoft.com/office/drawing/2014/main" xmlns="" id="{BD769EEA-D946-179F-08D4-47BB78901C83}"/>
+                <a16:creationId xmlns="" xmlns:a16="http://schemas.microsoft.com/office/drawing/2014/main" id="{BD769EEA-D946-179F-08D4-47BB78901C83}"/>
               </a:ext>
             </a:extLst>
           </p:cNvPr>
@@ -6948,7 +7144,7 @@
           <p:cNvPr id="7" name="Picture 6">
             <a:extLst>
               <a:ext uri="{FF2B5EF4-FFF2-40B4-BE49-F238E27FC236}">
-                <a16:creationId xmlns:a16="http://schemas.microsoft.com/office/drawing/2014/main" xmlns="" id="{C8D1549F-FDE0-A173-0365-C6C25AD858AE}"/>
+                <a16:creationId xmlns="" xmlns:a16="http://schemas.microsoft.com/office/drawing/2014/main" id="{C8D1549F-FDE0-A173-0365-C6C25AD858AE}"/>
               </a:ext>
             </a:extLst>
           </p:cNvPr>
@@ -6978,7 +7174,7 @@
           <p:cNvPr id="9" name="TextBox 8">
             <a:extLst>
               <a:ext uri="{FF2B5EF4-FFF2-40B4-BE49-F238E27FC236}">
-                <a16:creationId xmlns:a16="http://schemas.microsoft.com/office/drawing/2014/main" xmlns="" id="{466A50D6-4D7E-7801-3567-388C8D547942}"/>
+                <a16:creationId xmlns="" xmlns:a16="http://schemas.microsoft.com/office/drawing/2014/main" id="{466A50D6-4D7E-7801-3567-388C8D547942}"/>
               </a:ext>
             </a:extLst>
           </p:cNvPr>
@@ -7050,7 +7246,7 @@
           <p:cNvPr id="5" name="TextBox 4">
             <a:extLst>
               <a:ext uri="{FF2B5EF4-FFF2-40B4-BE49-F238E27FC236}">
-                <a16:creationId xmlns:a16="http://schemas.microsoft.com/office/drawing/2014/main" xmlns="" id="{8A3E8D89-63E3-5E2C-E7F9-907F4377B787}"/>
+                <a16:creationId xmlns="" xmlns:a16="http://schemas.microsoft.com/office/drawing/2014/main" id="{8A3E8D89-63E3-5E2C-E7F9-907F4377B787}"/>
               </a:ext>
             </a:extLst>
           </p:cNvPr>
@@ -7118,7 +7314,7 @@
           <p:cNvPr id="7" name="Picture 6">
             <a:extLst>
               <a:ext uri="{FF2B5EF4-FFF2-40B4-BE49-F238E27FC236}">
-                <a16:creationId xmlns:a16="http://schemas.microsoft.com/office/drawing/2014/main" xmlns="" id="{6D06A596-DD61-B2D3-1E14-AEE7B1C49815}"/>
+                <a16:creationId xmlns="" xmlns:a16="http://schemas.microsoft.com/office/drawing/2014/main" id="{6D06A596-DD61-B2D3-1E14-AEE7B1C49815}"/>
               </a:ext>
             </a:extLst>
           </p:cNvPr>
@@ -7178,7 +7374,7 @@
           <p:cNvPr id="5" name="Picture 4">
             <a:extLst>
               <a:ext uri="{FF2B5EF4-FFF2-40B4-BE49-F238E27FC236}">
-                <a16:creationId xmlns:a16="http://schemas.microsoft.com/office/drawing/2014/main" xmlns="" id="{FB0E639C-61D1-EB74-F186-183832276F38}"/>
+                <a16:creationId xmlns="" xmlns:a16="http://schemas.microsoft.com/office/drawing/2014/main" id="{FB0E639C-61D1-EB74-F186-183832276F38}"/>
               </a:ext>
             </a:extLst>
           </p:cNvPr>
@@ -7208,7 +7404,7 @@
           <p:cNvPr id="7" name="TextBox 6">
             <a:extLst>
               <a:ext uri="{FF2B5EF4-FFF2-40B4-BE49-F238E27FC236}">
-                <a16:creationId xmlns:a16="http://schemas.microsoft.com/office/drawing/2014/main" xmlns="" id="{AB05F51A-3870-0075-C920-16408C1851DF}"/>
+                <a16:creationId xmlns="" xmlns:a16="http://schemas.microsoft.com/office/drawing/2014/main" id="{AB05F51A-3870-0075-C920-16408C1851DF}"/>
               </a:ext>
             </a:extLst>
           </p:cNvPr>
@@ -7244,7 +7440,7 @@
           <p:cNvPr id="9" name="TextBox 8">
             <a:extLst>
               <a:ext uri="{FF2B5EF4-FFF2-40B4-BE49-F238E27FC236}">
-                <a16:creationId xmlns:a16="http://schemas.microsoft.com/office/drawing/2014/main" xmlns="" id="{B1F75ACB-D5D1-26D3-821F-3506F6F130E8}"/>
+                <a16:creationId xmlns="" xmlns:a16="http://schemas.microsoft.com/office/drawing/2014/main" id="{B1F75ACB-D5D1-26D3-821F-3506F6F130E8}"/>
               </a:ext>
             </a:extLst>
           </p:cNvPr>
@@ -7384,7 +7580,7 @@
           <p:cNvPr id="11" name="TextBox 10">
             <a:extLst>
               <a:ext uri="{FF2B5EF4-FFF2-40B4-BE49-F238E27FC236}">
-                <a16:creationId xmlns:a16="http://schemas.microsoft.com/office/drawing/2014/main" xmlns="" id="{01EE86E1-736D-647A-92DE-FF18315CBD64}"/>
+                <a16:creationId xmlns="" xmlns:a16="http://schemas.microsoft.com/office/drawing/2014/main" id="{01EE86E1-736D-647A-92DE-FF18315CBD64}"/>
               </a:ext>
             </a:extLst>
           </p:cNvPr>

</xml_diff>